<commit_message>
docs: add BFS / Dijkstra / DFS comparison annexes and flash answers
Co-Authored-By: Claude Opus 5 <noreply@anthropic.com>
</commit_message>
<xml_diff>
--- a/docs/Presentation_Une_vie_de_fourmi_Romain_Lisa_Yannis.pptx
+++ b/docs/Presentation_Une_vie_de_fourmi_Romain_Lisa_Yannis.pptx
@@ -20,6 +20,7 @@
     <p:sldId id="268" r:id="rId20"/>
     <p:sldId id="269" r:id="rId21"/>
     <p:sldId id="270" r:id="rId22"/>
+    <p:sldId id="271" r:id="rId23"/>
   </p:sldIdLst>
   <p:sldSz cx="12191695" cy="6858000" type="screen4x3"/>
   <p:notesSz cx="6858000" cy="9144000"/>
@@ -5049,7 +5050,7 @@
                 </a:solidFill>
                 <a:latin typeface="Calibri"/>
               </a:rPr>
-              <a:t>Min-cost flow : des trajets propres, sans changer T</a:t>
+              <a:t>Graphe temporel et découpage des salles</a:t>
             </a:r>
           </a:p>
         </p:txBody>
@@ -5088,7 +5089,7 @@
                 </a:solidFill>
                 <a:latin typeface="Calibri"/>
               </a:rPr>
-              <a:t>Optimisation lexicographique : chaque niveau pèse plus que tous les suivants réunis</a:t>
+              <a:t>Transformer « position + temps » en un problème de flot statique</a:t>
             </a:r>
           </a:p>
         </p:txBody>
@@ -5167,6 +5168,636 @@
                 <a:latin typeface="Calibri"/>
               </a:rPr>
               <a:t>10</a:t>
+            </a:r>
+          </a:p>
+        </p:txBody>
+      </p:sp>
+      <p:pic>
+        <p:nvPicPr>
+          <p:cNvPr id="7" name="Picture 6" descr="time_expanded.png"/>
+          <p:cNvPicPr>
+            <a:picLocks noChangeAspect="1"/>
+          </p:cNvPicPr>
+          <p:nvPr/>
+        </p:nvPicPr>
+        <p:blipFill>
+          <a:blip r:embed="rId2"/>
+          <a:stretch>
+            <a:fillRect/>
+          </a:stretch>
+        </p:blipFill>
+        <p:spPr>
+          <a:xfrm>
+            <a:off x="457200" y="1617379"/>
+            <a:ext cx="6309360" cy="3623242"/>
+          </a:xfrm>
+          <a:prstGeom prst="rect">
+            <a:avLst/>
+          </a:prstGeom>
+        </p:spPr>
+      </p:pic>
+      <p:sp>
+        <p:nvSpPr>
+          <p:cNvPr id="8" name="TextBox 7"/>
+          <p:cNvSpPr txBox="1"/>
+          <p:nvPr/>
+        </p:nvSpPr>
+        <p:spPr>
+          <a:xfrm>
+            <a:off x="7040880" y="1645920"/>
+            <a:ext cx="4663440" cy="731520"/>
+          </a:xfrm>
+          <a:prstGeom prst="rect">
+            <a:avLst/>
+          </a:prstGeom>
+          <a:noFill/>
+        </p:spPr>
+        <p:txBody>
+          <a:bodyPr wrap="square" lIns="0" rIns="0" tIns="0" bIns="0" anchor="t">
+            <a:spAutoFit/>
+          </a:bodyPr>
+          <a:lstStyle/>
+          <a:p>
+            <a:pPr algn="l">
+              <a:lnSpc>
+                <a:spcPct val="100000"/>
+              </a:lnSpc>
+            </a:pPr>
+            <a:r>
+              <a:rPr sz="1600" b="1" i="0">
+                <a:solidFill>
+                  <a:srgbClr val="0B1F2A"/>
+                </a:solidFill>
+                <a:latin typeface="Calibri"/>
+              </a:rPr>
+              <a:t>Sommets</a:t>
+            </a:r>
+          </a:p>
+          <a:p>
+            <a:pPr algn="l">
+              <a:lnSpc>
+                <a:spcPct val="100000"/>
+              </a:lnSpc>
+            </a:pPr>
+            <a:r>
+              <a:rPr sz="1350" b="0" i="0">
+                <a:solidFill>
+                  <a:srgbClr val="5B636A"/>
+                </a:solidFill>
+                <a:latin typeface="Calibri"/>
+              </a:rPr>
+              <a:t>(salle, t) pour chaque salle et chaque instant 0 … T</a:t>
+            </a:r>
+          </a:p>
+        </p:txBody>
+      </p:sp>
+      <p:sp>
+        <p:nvSpPr>
+          <p:cNvPr id="9" name="TextBox 8"/>
+          <p:cNvSpPr txBox="1"/>
+          <p:nvPr/>
+        </p:nvSpPr>
+        <p:spPr>
+          <a:xfrm>
+            <a:off x="7040880" y="2395728"/>
+            <a:ext cx="4663440" cy="731520"/>
+          </a:xfrm>
+          <a:prstGeom prst="rect">
+            <a:avLst/>
+          </a:prstGeom>
+          <a:noFill/>
+        </p:spPr>
+        <p:txBody>
+          <a:bodyPr wrap="square" lIns="0" rIns="0" tIns="0" bIns="0" anchor="t">
+            <a:spAutoFit/>
+          </a:bodyPr>
+          <a:lstStyle/>
+          <a:p>
+            <a:pPr algn="l">
+              <a:lnSpc>
+                <a:spcPct val="100000"/>
+              </a:lnSpc>
+            </a:pPr>
+            <a:r>
+              <a:rPr sz="1600" b="1" i="0">
+                <a:solidFill>
+                  <a:srgbClr val="0B1F2A"/>
+                </a:solidFill>
+                <a:latin typeface="Calibri"/>
+              </a:rPr>
+              <a:t>Attendre</a:t>
+            </a:r>
+          </a:p>
+          <a:p>
+            <a:pPr algn="l">
+              <a:lnSpc>
+                <a:spcPct val="100000"/>
+              </a:lnSpc>
+            </a:pPr>
+            <a:r>
+              <a:rPr sz="1350" b="0" i="0">
+                <a:solidFill>
+                  <a:srgbClr val="5B636A"/>
+                </a:solidFill>
+                <a:latin typeface="Calibri"/>
+              </a:rPr>
+              <a:t>(salle, t) → (salle, t+1)</a:t>
+            </a:r>
+          </a:p>
+        </p:txBody>
+      </p:sp>
+      <p:sp>
+        <p:nvSpPr>
+          <p:cNvPr id="10" name="TextBox 9"/>
+          <p:cNvSpPr txBox="1"/>
+          <p:nvPr/>
+        </p:nvSpPr>
+        <p:spPr>
+          <a:xfrm>
+            <a:off x="7040880" y="3145536"/>
+            <a:ext cx="4663440" cy="731520"/>
+          </a:xfrm>
+          <a:prstGeom prst="rect">
+            <a:avLst/>
+          </a:prstGeom>
+          <a:noFill/>
+        </p:spPr>
+        <p:txBody>
+          <a:bodyPr wrap="square" lIns="0" rIns="0" tIns="0" bIns="0" anchor="t">
+            <a:spAutoFit/>
+          </a:bodyPr>
+          <a:lstStyle/>
+          <a:p>
+            <a:pPr algn="l">
+              <a:lnSpc>
+                <a:spcPct val="100000"/>
+              </a:lnSpc>
+            </a:pPr>
+            <a:r>
+              <a:rPr sz="1600" b="1" i="0">
+                <a:solidFill>
+                  <a:srgbClr val="0B1F2A"/>
+                </a:solidFill>
+                <a:latin typeface="Calibri"/>
+              </a:rPr>
+              <a:t>Se déplacer</a:t>
+            </a:r>
+          </a:p>
+          <a:p>
+            <a:pPr algn="l">
+              <a:lnSpc>
+                <a:spcPct val="100000"/>
+              </a:lnSpc>
+            </a:pPr>
+            <a:r>
+              <a:rPr sz="1350" b="0" i="0">
+                <a:solidFill>
+                  <a:srgbClr val="5B636A"/>
+                </a:solidFill>
+                <a:latin typeface="Calibri"/>
+              </a:rPr>
+              <a:t>(a, t) → (b, t+1) si le tunnel a–b existe ; capacité illimitée</a:t>
+            </a:r>
+          </a:p>
+        </p:txBody>
+      </p:sp>
+      <p:sp>
+        <p:nvSpPr>
+          <p:cNvPr id="11" name="TextBox 10"/>
+          <p:cNvSpPr txBox="1"/>
+          <p:nvPr/>
+        </p:nvSpPr>
+        <p:spPr>
+          <a:xfrm>
+            <a:off x="7040880" y="3895344"/>
+            <a:ext cx="4663440" cy="731520"/>
+          </a:xfrm>
+          <a:prstGeom prst="rect">
+            <a:avLst/>
+          </a:prstGeom>
+          <a:noFill/>
+        </p:spPr>
+        <p:txBody>
+          <a:bodyPr wrap="square" lIns="0" rIns="0" tIns="0" bIns="0" anchor="t">
+            <a:spAutoFit/>
+          </a:bodyPr>
+          <a:lstStyle/>
+          <a:p>
+            <a:pPr algn="l">
+              <a:lnSpc>
+                <a:spcPct val="100000"/>
+              </a:lnSpc>
+            </a:pPr>
+            <a:r>
+              <a:rPr sz="1600" b="1" i="0">
+                <a:solidFill>
+                  <a:srgbClr val="0B1F2A"/>
+                </a:solidFill>
+                <a:latin typeface="Calibri"/>
+              </a:rPr>
+              <a:t>Capacité SN{X}</a:t>
+            </a:r>
+          </a:p>
+          <a:p>
+            <a:pPr algn="l">
+              <a:lnSpc>
+                <a:spcPct val="100000"/>
+              </a:lnSpc>
+            </a:pPr>
+            <a:r>
+              <a:rPr sz="1350" b="0" i="0">
+                <a:solidFill>
+                  <a:srgbClr val="5B636A"/>
+                </a:solidFill>
+                <a:latin typeface="Calibri"/>
+              </a:rPr>
+              <a:t>chaque (salle, t) est coupé en entrée → sortie de capacité X : c'est le node splitting</a:t>
+            </a:r>
+          </a:p>
+        </p:txBody>
+      </p:sp>
+      <p:sp>
+        <p:nvSpPr>
+          <p:cNvPr id="12" name="TextBox 11"/>
+          <p:cNvSpPr txBox="1"/>
+          <p:nvPr/>
+        </p:nvSpPr>
+        <p:spPr>
+          <a:xfrm>
+            <a:off x="7040880" y="4645152"/>
+            <a:ext cx="4663440" cy="731520"/>
+          </a:xfrm>
+          <a:prstGeom prst="rect">
+            <a:avLst/>
+          </a:prstGeom>
+          <a:noFill/>
+        </p:spPr>
+        <p:txBody>
+          <a:bodyPr wrap="square" lIns="0" rIns="0" tIns="0" bIns="0" anchor="t">
+            <a:spAutoFit/>
+          </a:bodyPr>
+          <a:lstStyle/>
+          <a:p>
+            <a:pPr algn="l">
+              <a:lnSpc>
+                <a:spcPct val="100000"/>
+              </a:lnSpc>
+            </a:pPr>
+            <a:r>
+              <a:rPr sz="1600" b="1" i="0">
+                <a:solidFill>
+                  <a:srgbClr val="0B1F2A"/>
+                </a:solidFill>
+                <a:latin typeface="Calibri"/>
+              </a:rPr>
+              <a:t>Sv et Sd</a:t>
+            </a:r>
+          </a:p>
+          <a:p>
+            <a:pPr algn="l">
+              <a:lnSpc>
+                <a:spcPct val="100000"/>
+              </a:lnSpc>
+            </a:pPr>
+            <a:r>
+              <a:rPr sz="1350" b="0" i="0">
+                <a:solidFill>
+                  <a:srgbClr val="5B636A"/>
+                </a:solidFill>
+                <a:latin typeface="Calibri"/>
+              </a:rPr>
+              <a:t>capacité F : jamais limitants ; Sd absorbant (on n'en ressort pas)</a:t>
+            </a:r>
+          </a:p>
+        </p:txBody>
+      </p:sp>
+      <p:sp>
+        <p:nvSpPr>
+          <p:cNvPr id="13" name="TextBox 12"/>
+          <p:cNvSpPr txBox="1"/>
+          <p:nvPr/>
+        </p:nvSpPr>
+        <p:spPr>
+          <a:xfrm>
+            <a:off x="7040880" y="5394960"/>
+            <a:ext cx="4663440" cy="731520"/>
+          </a:xfrm>
+          <a:prstGeom prst="rect">
+            <a:avLst/>
+          </a:prstGeom>
+          <a:noFill/>
+        </p:spPr>
+        <p:txBody>
+          <a:bodyPr wrap="square" lIns="0" rIns="0" tIns="0" bIns="0" anchor="t">
+            <a:spAutoFit/>
+          </a:bodyPr>
+          <a:lstStyle/>
+          <a:p>
+            <a:pPr algn="l">
+              <a:lnSpc>
+                <a:spcPct val="100000"/>
+              </a:lnSpc>
+            </a:pPr>
+            <a:r>
+              <a:rPr sz="1600" b="1" i="0">
+                <a:solidFill>
+                  <a:srgbClr val="0B1F2A"/>
+                </a:solidFill>
+                <a:latin typeface="Calibri"/>
+              </a:rPr>
+              <a:t>Une unité de flot</a:t>
+            </a:r>
+          </a:p>
+          <a:p>
+            <a:pPr algn="l">
+              <a:lnSpc>
+                <a:spcPct val="100000"/>
+              </a:lnSpc>
+            </a:pPr>
+            <a:r>
+              <a:rPr sz="1350" b="0" i="0">
+                <a:solidFill>
+                  <a:srgbClr val="5B636A"/>
+                </a:solidFill>
+                <a:latin typeface="Calibri"/>
+              </a:rPr>
+              <a:t>= une fourmi ; flot de valeur F = toutes les fourmis arrivent en T étapes</a:t>
+            </a:r>
+          </a:p>
+        </p:txBody>
+      </p:sp>
+      <p:sp>
+        <p:nvSpPr>
+          <p:cNvPr id="14" name="TextBox 13"/>
+          <p:cNvSpPr txBox="1"/>
+          <p:nvPr/>
+        </p:nvSpPr>
+        <p:spPr>
+          <a:xfrm>
+            <a:off x="548640" y="5669280"/>
+            <a:ext cx="6217920" cy="548640"/>
+          </a:xfrm>
+          <a:prstGeom prst="rect">
+            <a:avLst/>
+          </a:prstGeom>
+          <a:noFill/>
+        </p:spPr>
+        <p:txBody>
+          <a:bodyPr wrap="square" lIns="0" rIns="0" tIns="0" bIns="0" anchor="t">
+            <a:spAutoFit/>
+          </a:bodyPr>
+          <a:lstStyle/>
+          <a:p>
+            <a:pPr algn="l">
+              <a:lnSpc>
+                <a:spcPct val="100000"/>
+              </a:lnSpc>
+            </a:pPr>
+            <a:r>
+              <a:rPr sz="1300" b="0" i="0">
+                <a:solidFill>
+                  <a:srgbClr val="0B1F2A"/>
+                </a:solidFill>
+                <a:latin typeface="Calibri"/>
+              </a:rPr>
+              <a:t>Premier T faisable = optimum : si T marche, T+1 marche aussi (on attend dans Sd), et on teste T = d, d+1, … dans l'ordre.</a:t>
+            </a:r>
+          </a:p>
+        </p:txBody>
+      </p:sp>
+    </p:spTree>
+  </p:cSld>
+  <p:clrMapOvr>
+    <a:masterClrMapping/>
+  </p:clrMapOvr>
+</p:sld>
+</file>
+
+<file path=ppt/slides/slide11.xml><?xml version="1.0" encoding="utf-8"?>
+<p:sld xmlns:a="http://schemas.openxmlformats.org/drawingml/2006/main" xmlns:p="http://schemas.openxmlformats.org/presentationml/2006/main" xmlns:r="http://schemas.openxmlformats.org/officeDocument/2006/relationships">
+  <p:cSld>
+    <p:bg>
+      <p:bgPr>
+        <a:solidFill>
+          <a:srgbClr val="FFFFFF"/>
+        </a:solidFill>
+        <a:effectLst/>
+      </p:bgPr>
+    </p:bg>
+    <p:spTree>
+      <p:nvGrpSpPr>
+        <p:cNvPr id="1" name=""/>
+        <p:cNvGrpSpPr/>
+        <p:nvPr/>
+      </p:nvGrpSpPr>
+      <p:grpSpPr/>
+      <p:sp>
+        <p:nvSpPr>
+          <p:cNvPr id="2" name="Rounded Rectangle 1"/>
+          <p:cNvSpPr/>
+          <p:nvPr/>
+        </p:nvSpPr>
+        <p:spPr>
+          <a:xfrm>
+            <a:off x="10317176" y="384048"/>
+            <a:ext cx="1463040" cy="384048"/>
+          </a:xfrm>
+          <a:prstGeom prst="roundRect">
+            <a:avLst>
+              <a:gd name="adj" fmla="val 50000"/>
+            </a:avLst>
+          </a:prstGeom>
+          <a:solidFill>
+            <a:srgbClr val="F3F5F7"/>
+          </a:solidFill>
+          <a:ln>
+            <a:noFill/>
+          </a:ln>
+          <a:effectLst/>
+        </p:spPr>
+        <p:style>
+          <a:lnRef idx="1">
+            <a:schemeClr val="accent1"/>
+          </a:lnRef>
+          <a:fillRef idx="3">
+            <a:schemeClr val="accent1"/>
+          </a:fillRef>
+          <a:effectRef idx="2">
+            <a:schemeClr val="accent1"/>
+          </a:effectRef>
+          <a:fontRef idx="minor">
+            <a:schemeClr val="lt1"/>
+          </a:fontRef>
+        </p:style>
+        <p:txBody>
+          <a:bodyPr rtlCol="0" anchor="ctr" lIns="0" rIns="0"/>
+          <a:lstStyle/>
+          <a:p>
+            <a:pPr algn="ctr"/>
+            <a:r>
+              <a:rPr sz="1300" b="1">
+                <a:solidFill>
+                  <a:srgbClr val="5B636A"/>
+                </a:solidFill>
+                <a:latin typeface="Calibri"/>
+              </a:rPr>
+              <a:t>ANNEXE</a:t>
+            </a:r>
+          </a:p>
+        </p:txBody>
+      </p:sp>
+      <p:sp>
+        <p:nvSpPr>
+          <p:cNvPr id="3" name="TextBox 2"/>
+          <p:cNvSpPr txBox="1"/>
+          <p:nvPr/>
+        </p:nvSpPr>
+        <p:spPr>
+          <a:xfrm>
+            <a:off x="548640" y="347472"/>
+            <a:ext cx="9326880" cy="731520"/>
+          </a:xfrm>
+          <a:prstGeom prst="rect">
+            <a:avLst/>
+          </a:prstGeom>
+          <a:noFill/>
+        </p:spPr>
+        <p:txBody>
+          <a:bodyPr wrap="square" lIns="0" rIns="0" tIns="0" bIns="0" anchor="t">
+            <a:spAutoFit/>
+          </a:bodyPr>
+          <a:lstStyle/>
+          <a:p>
+            <a:pPr algn="l">
+              <a:lnSpc>
+                <a:spcPct val="100000"/>
+              </a:lnSpc>
+            </a:pPr>
+            <a:r>
+              <a:rPr sz="3000" b="1" i="0">
+                <a:solidFill>
+                  <a:srgbClr val="0B1F2A"/>
+                </a:solidFill>
+                <a:latin typeface="Calibri"/>
+              </a:rPr>
+              <a:t>Min-cost flow : des trajets propres, sans changer T</a:t>
+            </a:r>
+          </a:p>
+        </p:txBody>
+      </p:sp>
+      <p:sp>
+        <p:nvSpPr>
+          <p:cNvPr id="4" name="TextBox 3"/>
+          <p:cNvSpPr txBox="1"/>
+          <p:nvPr/>
+        </p:nvSpPr>
+        <p:spPr>
+          <a:xfrm>
+            <a:off x="548640" y="1024128"/>
+            <a:ext cx="9326880" cy="411480"/>
+          </a:xfrm>
+          <a:prstGeom prst="rect">
+            <a:avLst/>
+          </a:prstGeom>
+          <a:noFill/>
+        </p:spPr>
+        <p:txBody>
+          <a:bodyPr wrap="square" lIns="0" rIns="0" tIns="0" bIns="0" anchor="t">
+            <a:spAutoFit/>
+          </a:bodyPr>
+          <a:lstStyle/>
+          <a:p>
+            <a:pPr algn="l">
+              <a:lnSpc>
+                <a:spcPct val="100000"/>
+              </a:lnSpc>
+            </a:pPr>
+            <a:r>
+              <a:rPr sz="1700" b="0" i="0">
+                <a:solidFill>
+                  <a:srgbClr val="5B636A"/>
+                </a:solidFill>
+                <a:latin typeface="Calibri"/>
+              </a:rPr>
+              <a:t>Optimisation lexicographique : chaque niveau pèse plus que tous les suivants réunis</a:t>
+            </a:r>
+          </a:p>
+        </p:txBody>
+      </p:sp>
+      <p:sp>
+        <p:nvSpPr>
+          <p:cNvPr id="5" name="TextBox 4"/>
+          <p:cNvSpPr txBox="1"/>
+          <p:nvPr/>
+        </p:nvSpPr>
+        <p:spPr>
+          <a:xfrm>
+            <a:off x="548640" y="6473952"/>
+            <a:ext cx="5486400" cy="274320"/>
+          </a:xfrm>
+          <a:prstGeom prst="rect">
+            <a:avLst/>
+          </a:prstGeom>
+          <a:noFill/>
+        </p:spPr>
+        <p:txBody>
+          <a:bodyPr wrap="square" lIns="0" rIns="0" tIns="0" bIns="0" anchor="t">
+            <a:spAutoFit/>
+          </a:bodyPr>
+          <a:lstStyle/>
+          <a:p>
+            <a:pPr algn="l">
+              <a:lnSpc>
+                <a:spcPct val="100000"/>
+              </a:lnSpc>
+            </a:pPr>
+            <a:r>
+              <a:rPr sz="1000" b="0" i="0">
+                <a:solidFill>
+                  <a:srgbClr val="5B636A"/>
+                </a:solidFill>
+                <a:latin typeface="Calibri"/>
+              </a:rPr>
+              <a:t>Une vie de fourmi · Romain · Lisa · Yannis</a:t>
+            </a:r>
+          </a:p>
+        </p:txBody>
+      </p:sp>
+      <p:sp>
+        <p:nvSpPr>
+          <p:cNvPr id="6" name="TextBox 5"/>
+          <p:cNvSpPr txBox="1"/>
+          <p:nvPr/>
+        </p:nvSpPr>
+        <p:spPr>
+          <a:xfrm>
+            <a:off x="11185855" y="6473952"/>
+            <a:ext cx="457200" cy="274320"/>
+          </a:xfrm>
+          <a:prstGeom prst="rect">
+            <a:avLst/>
+          </a:prstGeom>
+          <a:noFill/>
+        </p:spPr>
+        <p:txBody>
+          <a:bodyPr wrap="square" lIns="0" rIns="0" tIns="0" bIns="0" anchor="t">
+            <a:spAutoFit/>
+          </a:bodyPr>
+          <a:lstStyle/>
+          <a:p>
+            <a:pPr algn="r">
+              <a:lnSpc>
+                <a:spcPct val="100000"/>
+              </a:lnSpc>
+            </a:pPr>
+            <a:r>
+              <a:rPr sz="1000" b="0" i="0">
+                <a:solidFill>
+                  <a:srgbClr val="5B636A"/>
+                </a:solidFill>
+                <a:latin typeface="Calibri"/>
+              </a:rPr>
+              <a:t>11</a:t>
             </a:r>
           </a:p>
         </p:txBody>
@@ -5750,7 +6381,7 @@
 </p:sld>
 </file>
 
-<file path=ppt/slides/slide11.xml><?xml version="1.0" encoding="utf-8"?>
+<file path=ppt/slides/slide12.xml><?xml version="1.0" encoding="utf-8"?>
 <p:sld xmlns:a="http://schemas.openxmlformats.org/drawingml/2006/main" xmlns:p="http://schemas.openxmlformats.org/presentationml/2006/main" xmlns:r="http://schemas.openxmlformats.org/officeDocument/2006/relationships">
   <p:cSld>
     <p:bg>
@@ -5974,7 +6605,7 @@
                 </a:solidFill>
                 <a:latin typeface="Calibri"/>
               </a:rPr>
-              <a:t>11</a:t>
+              <a:t>12</a:t>
             </a:r>
           </a:p>
         </p:txBody>
@@ -6664,7 +7295,7 @@
 </p:sld>
 </file>
 
-<file path=ppt/slides/slide12.xml><?xml version="1.0" encoding="utf-8"?>
+<file path=ppt/slides/slide13.xml><?xml version="1.0" encoding="utf-8"?>
 <p:sld xmlns:a="http://schemas.openxmlformats.org/drawingml/2006/main" xmlns:p="http://schemas.openxmlformats.org/presentationml/2006/main" xmlns:r="http://schemas.openxmlformats.org/officeDocument/2006/relationships">
   <p:cSld>
     <p:bg>
@@ -6888,7 +7519,7 @@
                 </a:solidFill>
                 <a:latin typeface="Calibri"/>
               </a:rPr>
-              <a:t>12</a:t>
+              <a:t>13</a:t>
             </a:r>
           </a:p>
         </p:txBody>
@@ -7339,7 +7970,7 @@
                           </a:solidFill>
                           <a:latin typeface="Calibri"/>
                         </a:rPr>
-                        <a:t>5 ms</a:t>
+                        <a:t>6 ms</a:t>
                       </a:r>
                     </a:p>
                   </a:txBody>
@@ -7621,7 +8252,7 @@
                           </a:solidFill>
                           <a:latin typeface="Calibri"/>
                         </a:rPr>
-                        <a:t>17 ms</a:t>
+                        <a:t>21 ms</a:t>
                       </a:r>
                     </a:p>
                   </a:txBody>
@@ -7715,7 +8346,7 @@
                           </a:solidFill>
                           <a:latin typeface="Calibri"/>
                         </a:rPr>
-                        <a:t>66 ms</a:t>
+                        <a:t>74 ms</a:t>
                       </a:r>
                     </a:p>
                   </a:txBody>
@@ -7809,7 +8440,7 @@
                           </a:solidFill>
                           <a:latin typeface="Calibri"/>
                         </a:rPr>
-                        <a:t>67 ms</a:t>
+                        <a:t>89 ms</a:t>
                       </a:r>
                     </a:p>
                   </a:txBody>
@@ -7903,7 +8534,7 @@
                           </a:solidFill>
                           <a:latin typeface="Calibri"/>
                         </a:rPr>
-                        <a:t>50 ms</a:t>
+                        <a:t>51 ms</a:t>
                       </a:r>
                     </a:p>
                   </a:txBody>
@@ -7997,7 +8628,7 @@
                           </a:solidFill>
                           <a:latin typeface="Calibri"/>
                         </a:rPr>
-                        <a:t>243 ms</a:t>
+                        <a:t>263 ms</a:t>
                       </a:r>
                     </a:p>
                   </a:txBody>
@@ -8012,849 +8643,6 @@
           </a:graphicData>
         </a:graphic>
       </p:graphicFrame>
-    </p:spTree>
-  </p:cSld>
-  <p:clrMapOvr>
-    <a:masterClrMapping/>
-  </p:clrMapOvr>
-</p:sld>
-</file>
-
-<file path=ppt/slides/slide13.xml><?xml version="1.0" encoding="utf-8"?>
-<p:sld xmlns:a="http://schemas.openxmlformats.org/drawingml/2006/main" xmlns:p="http://schemas.openxmlformats.org/presentationml/2006/main" xmlns:r="http://schemas.openxmlformats.org/officeDocument/2006/relationships">
-  <p:cSld>
-    <p:bg>
-      <p:bgPr>
-        <a:solidFill>
-          <a:srgbClr val="FFFFFF"/>
-        </a:solidFill>
-        <a:effectLst/>
-      </p:bgPr>
-    </p:bg>
-    <p:spTree>
-      <p:nvGrpSpPr>
-        <p:cNvPr id="1" name=""/>
-        <p:cNvGrpSpPr/>
-        <p:nvPr/>
-      </p:nvGrpSpPr>
-      <p:grpSpPr/>
-      <p:sp>
-        <p:nvSpPr>
-          <p:cNvPr id="2" name="Rounded Rectangle 1"/>
-          <p:cNvSpPr/>
-          <p:nvPr/>
-        </p:nvSpPr>
-        <p:spPr>
-          <a:xfrm>
-            <a:off x="10317176" y="384048"/>
-            <a:ext cx="1463040" cy="384048"/>
-          </a:xfrm>
-          <a:prstGeom prst="roundRect">
-            <a:avLst>
-              <a:gd name="adj" fmla="val 50000"/>
-            </a:avLst>
-          </a:prstGeom>
-          <a:solidFill>
-            <a:srgbClr val="F3F5F7"/>
-          </a:solidFill>
-          <a:ln>
-            <a:noFill/>
-          </a:ln>
-          <a:effectLst/>
-        </p:spPr>
-        <p:style>
-          <a:lnRef idx="1">
-            <a:schemeClr val="accent1"/>
-          </a:lnRef>
-          <a:fillRef idx="3">
-            <a:schemeClr val="accent1"/>
-          </a:fillRef>
-          <a:effectRef idx="2">
-            <a:schemeClr val="accent1"/>
-          </a:effectRef>
-          <a:fontRef idx="minor">
-            <a:schemeClr val="lt1"/>
-          </a:fontRef>
-        </p:style>
-        <p:txBody>
-          <a:bodyPr rtlCol="0" anchor="ctr" lIns="0" rIns="0"/>
-          <a:lstStyle/>
-          <a:p>
-            <a:pPr algn="ctr"/>
-            <a:r>
-              <a:rPr sz="1300" b="1">
-                <a:solidFill>
-                  <a:srgbClr val="5B636A"/>
-                </a:solidFill>
-                <a:latin typeface="Calibri"/>
-              </a:rPr>
-              <a:t>ANNEXE</a:t>
-            </a:r>
-          </a:p>
-        </p:txBody>
-      </p:sp>
-      <p:sp>
-        <p:nvSpPr>
-          <p:cNvPr id="3" name="TextBox 2"/>
-          <p:cNvSpPr txBox="1"/>
-          <p:nvPr/>
-        </p:nvSpPr>
-        <p:spPr>
-          <a:xfrm>
-            <a:off x="548640" y="347472"/>
-            <a:ext cx="9326880" cy="731520"/>
-          </a:xfrm>
-          <a:prstGeom prst="rect">
-            <a:avLst/>
-          </a:prstGeom>
-          <a:noFill/>
-        </p:spPr>
-        <p:txBody>
-          <a:bodyPr wrap="square" lIns="0" rIns="0" tIns="0" bIns="0" anchor="t">
-            <a:spAutoFit/>
-          </a:bodyPr>
-          <a:lstStyle/>
-          <a:p>
-            <a:pPr algn="l">
-              <a:lnSpc>
-                <a:spcPct val="100000"/>
-              </a:lnSpc>
-            </a:pPr>
-            <a:r>
-              <a:rPr sz="3000" b="1" i="0">
-                <a:solidFill>
-                  <a:srgbClr val="0B1F2A"/>
-                </a:solidFill>
-                <a:latin typeface="Calibri"/>
-              </a:rPr>
-              <a:t>Comment on sait que c'est juste</a:t>
-            </a:r>
-          </a:p>
-        </p:txBody>
-      </p:sp>
-      <p:sp>
-        <p:nvSpPr>
-          <p:cNvPr id="4" name="TextBox 3"/>
-          <p:cNvSpPr txBox="1"/>
-          <p:nvPr/>
-        </p:nvSpPr>
-        <p:spPr>
-          <a:xfrm>
-            <a:off x="548640" y="1024128"/>
-            <a:ext cx="9326880" cy="411480"/>
-          </a:xfrm>
-          <a:prstGeom prst="rect">
-            <a:avLst/>
-          </a:prstGeom>
-          <a:noFill/>
-        </p:spPr>
-        <p:txBody>
-          <a:bodyPr wrap="square" lIns="0" rIns="0" tIns="0" bIns="0" anchor="t">
-            <a:spAutoFit/>
-          </a:bodyPr>
-          <a:lstStyle/>
-          <a:p>
-            <a:pPr algn="l">
-              <a:lnSpc>
-                <a:spcPct val="100000"/>
-              </a:lnSpc>
-            </a:pPr>
-            <a:r>
-              <a:rPr sz="1700" b="0" i="0">
-                <a:solidFill>
-                  <a:srgbClr val="5B636A"/>
-                </a:solidFill>
-                <a:latin typeface="Calibri"/>
-              </a:rPr>
-              <a:t>56 tests automatiques, lancés à chaque push par GitHub Actions</a:t>
-            </a:r>
-          </a:p>
-        </p:txBody>
-      </p:sp>
-      <p:sp>
-        <p:nvSpPr>
-          <p:cNvPr id="5" name="TextBox 4"/>
-          <p:cNvSpPr txBox="1"/>
-          <p:nvPr/>
-        </p:nvSpPr>
-        <p:spPr>
-          <a:xfrm>
-            <a:off x="548640" y="6473952"/>
-            <a:ext cx="5486400" cy="274320"/>
-          </a:xfrm>
-          <a:prstGeom prst="rect">
-            <a:avLst/>
-          </a:prstGeom>
-          <a:noFill/>
-        </p:spPr>
-        <p:txBody>
-          <a:bodyPr wrap="square" lIns="0" rIns="0" tIns="0" bIns="0" anchor="t">
-            <a:spAutoFit/>
-          </a:bodyPr>
-          <a:lstStyle/>
-          <a:p>
-            <a:pPr algn="l">
-              <a:lnSpc>
-                <a:spcPct val="100000"/>
-              </a:lnSpc>
-            </a:pPr>
-            <a:r>
-              <a:rPr sz="1000" b="0" i="0">
-                <a:solidFill>
-                  <a:srgbClr val="5B636A"/>
-                </a:solidFill>
-                <a:latin typeface="Calibri"/>
-              </a:rPr>
-              <a:t>Une vie de fourmi · Romain · Lisa · Yannis</a:t>
-            </a:r>
-          </a:p>
-        </p:txBody>
-      </p:sp>
-      <p:sp>
-        <p:nvSpPr>
-          <p:cNvPr id="6" name="TextBox 5"/>
-          <p:cNvSpPr txBox="1"/>
-          <p:nvPr/>
-        </p:nvSpPr>
-        <p:spPr>
-          <a:xfrm>
-            <a:off x="11185855" y="6473952"/>
-            <a:ext cx="457200" cy="274320"/>
-          </a:xfrm>
-          <a:prstGeom prst="rect">
-            <a:avLst/>
-          </a:prstGeom>
-          <a:noFill/>
-        </p:spPr>
-        <p:txBody>
-          <a:bodyPr wrap="square" lIns="0" rIns="0" tIns="0" bIns="0" anchor="t">
-            <a:spAutoFit/>
-          </a:bodyPr>
-          <a:lstStyle/>
-          <a:p>
-            <a:pPr algn="r">
-              <a:lnSpc>
-                <a:spcPct val="100000"/>
-              </a:lnSpc>
-            </a:pPr>
-            <a:r>
-              <a:rPr sz="1000" b="0" i="0">
-                <a:solidFill>
-                  <a:srgbClr val="5B636A"/>
-                </a:solidFill>
-                <a:latin typeface="Calibri"/>
-              </a:rPr>
-              <a:t>13</a:t>
-            </a:r>
-          </a:p>
-        </p:txBody>
-      </p:sp>
-      <p:sp>
-        <p:nvSpPr>
-          <p:cNvPr id="7" name="Rounded Rectangle 6"/>
-          <p:cNvSpPr/>
-          <p:nvPr/>
-        </p:nvSpPr>
-        <p:spPr>
-          <a:xfrm>
-            <a:off x="548640" y="1645920"/>
-            <a:ext cx="5440680" cy="1298448"/>
-          </a:xfrm>
-          <a:prstGeom prst="roundRect">
-            <a:avLst>
-              <a:gd name="adj" fmla="val 8000"/>
-            </a:avLst>
-          </a:prstGeom>
-          <a:solidFill>
-            <a:srgbClr val="F3F5F7"/>
-          </a:solidFill>
-          <a:ln>
-            <a:noFill/>
-          </a:ln>
-          <a:effectLst/>
-        </p:spPr>
-        <p:style>
-          <a:lnRef idx="1">
-            <a:schemeClr val="accent1"/>
-          </a:lnRef>
-          <a:fillRef idx="3">
-            <a:schemeClr val="accent1"/>
-          </a:fillRef>
-          <a:effectRef idx="2">
-            <a:schemeClr val="accent1"/>
-          </a:effectRef>
-          <a:fontRef idx="minor">
-            <a:schemeClr val="lt1"/>
-          </a:fontRef>
-        </p:style>
-        <p:txBody>
-          <a:bodyPr rtlCol="0" anchor="ctr" lIns="0" rIns="0"/>
-          <a:lstStyle/>
-          <a:p>
-            <a:pPr algn="ctr"/>
-          </a:p>
-        </p:txBody>
-      </p:sp>
-      <p:sp>
-        <p:nvSpPr>
-          <p:cNvPr id="8" name="TextBox 7"/>
-          <p:cNvSpPr txBox="1"/>
-          <p:nvPr/>
-        </p:nvSpPr>
-        <p:spPr>
-          <a:xfrm>
-            <a:off x="777240" y="1783080"/>
-            <a:ext cx="5029200" cy="1097280"/>
-          </a:xfrm>
-          <a:prstGeom prst="rect">
-            <a:avLst/>
-          </a:prstGeom>
-          <a:noFill/>
-        </p:spPr>
-        <p:txBody>
-          <a:bodyPr wrap="square" lIns="0" rIns="0" tIns="0" bIns="0" anchor="t">
-            <a:spAutoFit/>
-          </a:bodyPr>
-          <a:lstStyle/>
-          <a:p>
-            <a:pPr algn="l">
-              <a:lnSpc>
-                <a:spcPct val="100000"/>
-              </a:lnSpc>
-            </a:pPr>
-            <a:r>
-              <a:rPr sz="1700" b="1" i="0">
-                <a:solidFill>
-                  <a:srgbClr val="0B1F2A"/>
-                </a:solidFill>
-                <a:latin typeface="Calibri"/>
-              </a:rPr>
-              <a:t>Parseur</a:t>
-            </a:r>
-          </a:p>
-          <a:p>
-            <a:pPr algn="l">
-              <a:lnSpc>
-                <a:spcPct val="100000"/>
-              </a:lnSpc>
-            </a:pPr>
-            <a:r>
-              <a:rPr sz="1350" b="0" i="0">
-                <a:solidFill>
-                  <a:srgbClr val="5B636A"/>
-                </a:solidFill>
-                <a:latin typeface="Calibri"/>
-              </a:rPr>
-              <a:t>S1 { 5 }, f=50, F = 100, BOM, CRLF, tabulations, commentaires ; erreurs avec numéro de ligne ; capacités contradictoires</a:t>
-            </a:r>
-          </a:p>
-        </p:txBody>
-      </p:sp>
-      <p:sp>
-        <p:nvSpPr>
-          <p:cNvPr id="9" name="Rounded Rectangle 8"/>
-          <p:cNvSpPr/>
-          <p:nvPr/>
-        </p:nvSpPr>
-        <p:spPr>
-          <a:xfrm>
-            <a:off x="6172200" y="1645920"/>
-            <a:ext cx="5440680" cy="1298448"/>
-          </a:xfrm>
-          <a:prstGeom prst="roundRect">
-            <a:avLst>
-              <a:gd name="adj" fmla="val 8000"/>
-            </a:avLst>
-          </a:prstGeom>
-          <a:solidFill>
-            <a:srgbClr val="F3F5F7"/>
-          </a:solidFill>
-          <a:ln>
-            <a:noFill/>
-          </a:ln>
-          <a:effectLst/>
-        </p:spPr>
-        <p:style>
-          <a:lnRef idx="1">
-            <a:schemeClr val="accent1"/>
-          </a:lnRef>
-          <a:fillRef idx="3">
-            <a:schemeClr val="accent1"/>
-          </a:fillRef>
-          <a:effectRef idx="2">
-            <a:schemeClr val="accent1"/>
-          </a:effectRef>
-          <a:fontRef idx="minor">
-            <a:schemeClr val="lt1"/>
-          </a:fontRef>
-        </p:style>
-        <p:txBody>
-          <a:bodyPr rtlCol="0" anchor="ctr" lIns="0" rIns="0"/>
-          <a:lstStyle/>
-          <a:p>
-            <a:pPr algn="ctr"/>
-          </a:p>
-        </p:txBody>
-      </p:sp>
-      <p:sp>
-        <p:nvSpPr>
-          <p:cNvPr id="10" name="TextBox 9"/>
-          <p:cNvSpPr txBox="1"/>
-          <p:nvPr/>
-        </p:nvSpPr>
-        <p:spPr>
-          <a:xfrm>
-            <a:off x="6400800" y="1783080"/>
-            <a:ext cx="5029200" cy="1097280"/>
-          </a:xfrm>
-          <a:prstGeom prst="rect">
-            <a:avLst/>
-          </a:prstGeom>
-          <a:noFill/>
-        </p:spPr>
-        <p:txBody>
-          <a:bodyPr wrap="square" lIns="0" rIns="0" tIns="0" bIns="0" anchor="t">
-            <a:spAutoFit/>
-          </a:bodyPr>
-          <a:lstStyle/>
-          <a:p>
-            <a:pPr algn="l">
-              <a:lnSpc>
-                <a:spcPct val="100000"/>
-              </a:lnSpc>
-            </a:pPr>
-            <a:r>
-              <a:rPr sz="1700" b="1" i="0">
-                <a:solidFill>
-                  <a:srgbClr val="0B1F2A"/>
-                </a:solidFill>
-                <a:latin typeface="Calibri"/>
-              </a:rPr>
-              <a:t>Règles</a:t>
-            </a:r>
-          </a:p>
-          <a:p>
-            <a:pPr algn="l">
-              <a:lnSpc>
-                <a:spcPct val="100000"/>
-              </a:lnSpc>
-            </a:pPr>
-            <a:r>
-              <a:rPr sz="1350" b="0" i="0">
-                <a:solidFill>
-                  <a:srgbClr val="5B636A"/>
-                </a:solidFill>
-                <a:latin typeface="Calibri"/>
-              </a:rPr>
-              <a:t>capacités à chaque instant, tunnels existants, départ Sv, arrivée Sd, Sd absorbant, nombre exact de fourmis</a:t>
-            </a:r>
-          </a:p>
-        </p:txBody>
-      </p:sp>
-      <p:sp>
-        <p:nvSpPr>
-          <p:cNvPr id="11" name="Rounded Rectangle 10"/>
-          <p:cNvSpPr/>
-          <p:nvPr/>
-        </p:nvSpPr>
-        <p:spPr>
-          <a:xfrm>
-            <a:off x="548640" y="3108960"/>
-            <a:ext cx="5440680" cy="1298448"/>
-          </a:xfrm>
-          <a:prstGeom prst="roundRect">
-            <a:avLst>
-              <a:gd name="adj" fmla="val 8000"/>
-            </a:avLst>
-          </a:prstGeom>
-          <a:solidFill>
-            <a:srgbClr val="F3F5F7"/>
-          </a:solidFill>
-          <a:ln>
-            <a:noFill/>
-          </a:ln>
-          <a:effectLst/>
-        </p:spPr>
-        <p:style>
-          <a:lnRef idx="1">
-            <a:schemeClr val="accent1"/>
-          </a:lnRef>
-          <a:fillRef idx="3">
-            <a:schemeClr val="accent1"/>
-          </a:fillRef>
-          <a:effectRef idx="2">
-            <a:schemeClr val="accent1"/>
-          </a:effectRef>
-          <a:fontRef idx="minor">
-            <a:schemeClr val="lt1"/>
-          </a:fontRef>
-        </p:style>
-        <p:txBody>
-          <a:bodyPr rtlCol="0" anchor="ctr" lIns="0" rIns="0"/>
-          <a:lstStyle/>
-          <a:p>
-            <a:pPr algn="ctr"/>
-          </a:p>
-        </p:txBody>
-      </p:sp>
-      <p:sp>
-        <p:nvSpPr>
-          <p:cNvPr id="12" name="TextBox 11"/>
-          <p:cNvSpPr txBox="1"/>
-          <p:nvPr/>
-        </p:nvSpPr>
-        <p:spPr>
-          <a:xfrm>
-            <a:off x="777240" y="3246120"/>
-            <a:ext cx="5029200" cy="1097280"/>
-          </a:xfrm>
-          <a:prstGeom prst="rect">
-            <a:avLst/>
-          </a:prstGeom>
-          <a:noFill/>
-        </p:spPr>
-        <p:txBody>
-          <a:bodyPr wrap="square" lIns="0" rIns="0" tIns="0" bIns="0" anchor="t">
-            <a:spAutoFit/>
-          </a:bodyPr>
-          <a:lstStyle/>
-          <a:p>
-            <a:pPr algn="l">
-              <a:lnSpc>
-                <a:spcPct val="100000"/>
-              </a:lnSpc>
-            </a:pPr>
-            <a:r>
-              <a:rPr sz="1700" b="1" i="0">
-                <a:solidFill>
-                  <a:srgbClr val="0B1F2A"/>
-                </a:solidFill>
-                <a:latin typeface="Calibri"/>
-              </a:rPr>
-              <a:t>Topologies</a:t>
-            </a:r>
-          </a:p>
-          <a:p>
-            <a:pPr algn="l">
-              <a:lnSpc>
-                <a:spcPct val="100000"/>
-              </a:lnSpc>
-            </a:pPr>
-            <a:r>
-              <a:rPr sz="1350" b="0" i="0">
-                <a:solidFill>
-                  <a:srgbClr val="5B636A"/>
-                </a:solidFill>
-                <a:latin typeface="Calibri"/>
-              </a:rPr>
-              <a:t>cul-de-sac, cycle, tunnel direct Sv–Sd, grosse capacité, goulot, F = 100</a:t>
-            </a:r>
-          </a:p>
-        </p:txBody>
-      </p:sp>
-      <p:sp>
-        <p:nvSpPr>
-          <p:cNvPr id="13" name="Rounded Rectangle 12"/>
-          <p:cNvSpPr/>
-          <p:nvPr/>
-        </p:nvSpPr>
-        <p:spPr>
-          <a:xfrm>
-            <a:off x="6172200" y="3108960"/>
-            <a:ext cx="5440680" cy="1298448"/>
-          </a:xfrm>
-          <a:prstGeom prst="roundRect">
-            <a:avLst>
-              <a:gd name="adj" fmla="val 8000"/>
-            </a:avLst>
-          </a:prstGeom>
-          <a:solidFill>
-            <a:srgbClr val="F3F5F7"/>
-          </a:solidFill>
-          <a:ln>
-            <a:noFill/>
-          </a:ln>
-          <a:effectLst/>
-        </p:spPr>
-        <p:style>
-          <a:lnRef idx="1">
-            <a:schemeClr val="accent1"/>
-          </a:lnRef>
-          <a:fillRef idx="3">
-            <a:schemeClr val="accent1"/>
-          </a:fillRef>
-          <a:effectRef idx="2">
-            <a:schemeClr val="accent1"/>
-          </a:effectRef>
-          <a:fontRef idx="minor">
-            <a:schemeClr val="lt1"/>
-          </a:fontRef>
-        </p:style>
-        <p:txBody>
-          <a:bodyPr rtlCol="0" anchor="ctr" lIns="0" rIns="0"/>
-          <a:lstStyle/>
-          <a:p>
-            <a:pPr algn="ctr"/>
-          </a:p>
-        </p:txBody>
-      </p:sp>
-      <p:sp>
-        <p:nvSpPr>
-          <p:cNvPr id="14" name="TextBox 13"/>
-          <p:cNvSpPr txBox="1"/>
-          <p:nvPr/>
-        </p:nvSpPr>
-        <p:spPr>
-          <a:xfrm>
-            <a:off x="6400800" y="3246120"/>
-            <a:ext cx="5029200" cy="1097280"/>
-          </a:xfrm>
-          <a:prstGeom prst="rect">
-            <a:avLst/>
-          </a:prstGeom>
-          <a:noFill/>
-        </p:spPr>
-        <p:txBody>
-          <a:bodyPr wrap="square" lIns="0" rIns="0" tIns="0" bIns="0" anchor="t">
-            <a:spAutoFit/>
-          </a:bodyPr>
-          <a:lstStyle/>
-          <a:p>
-            <a:pPr algn="l">
-              <a:lnSpc>
-                <a:spcPct val="100000"/>
-              </a:lnSpc>
-            </a:pPr>
-            <a:r>
-              <a:rPr sz="1700" b="1" i="0">
-                <a:solidFill>
-                  <a:srgbClr val="0B1F2A"/>
-                </a:solidFill>
-                <a:latin typeface="Calibri"/>
-              </a:rPr>
-              <a:t>Optimalité</a:t>
-            </a:r>
-          </a:p>
-          <a:p>
-            <a:pPr algn="l">
-              <a:lnSpc>
-                <a:spcPct val="100000"/>
-              </a:lnSpc>
-            </a:pPr>
-            <a:r>
-              <a:rPr sz="1350" b="0" i="0">
-                <a:solidFill>
-                  <a:srgbClr val="5B636A"/>
-                </a:solidFill>
-                <a:latin typeface="Calibri"/>
-              </a:rPr>
-              <a:t>max-flow insuffisant à T − 1 ; 400 graphes aléatoires comparés à une recherche exhaustive (BFS sur les états)</a:t>
-            </a:r>
-          </a:p>
-        </p:txBody>
-      </p:sp>
-      <p:sp>
-        <p:nvSpPr>
-          <p:cNvPr id="15" name="Rounded Rectangle 14"/>
-          <p:cNvSpPr/>
-          <p:nvPr/>
-        </p:nvSpPr>
-        <p:spPr>
-          <a:xfrm>
-            <a:off x="548640" y="4572000"/>
-            <a:ext cx="5440680" cy="1298448"/>
-          </a:xfrm>
-          <a:prstGeom prst="roundRect">
-            <a:avLst>
-              <a:gd name="adj" fmla="val 8000"/>
-            </a:avLst>
-          </a:prstGeom>
-          <a:solidFill>
-            <a:srgbClr val="F3F5F7"/>
-          </a:solidFill>
-          <a:ln>
-            <a:noFill/>
-          </a:ln>
-          <a:effectLst/>
-        </p:spPr>
-        <p:style>
-          <a:lnRef idx="1">
-            <a:schemeClr val="accent1"/>
-          </a:lnRef>
-          <a:fillRef idx="3">
-            <a:schemeClr val="accent1"/>
-          </a:fillRef>
-          <a:effectRef idx="2">
-            <a:schemeClr val="accent1"/>
-          </a:effectRef>
-          <a:fontRef idx="minor">
-            <a:schemeClr val="lt1"/>
-          </a:fontRef>
-        </p:style>
-        <p:txBody>
-          <a:bodyPr rtlCol="0" anchor="ctr" lIns="0" rIns="0"/>
-          <a:lstStyle/>
-          <a:p>
-            <a:pPr algn="ctr"/>
-          </a:p>
-        </p:txBody>
-      </p:sp>
-      <p:sp>
-        <p:nvSpPr>
-          <p:cNvPr id="16" name="TextBox 15"/>
-          <p:cNvSpPr txBox="1"/>
-          <p:nvPr/>
-        </p:nvSpPr>
-        <p:spPr>
-          <a:xfrm>
-            <a:off x="777240" y="4709160"/>
-            <a:ext cx="5029200" cy="1097280"/>
-          </a:xfrm>
-          <a:prstGeom prst="rect">
-            <a:avLst/>
-          </a:prstGeom>
-          <a:noFill/>
-        </p:spPr>
-        <p:txBody>
-          <a:bodyPr wrap="square" lIns="0" rIns="0" tIns="0" bIns="0" anchor="t">
-            <a:spAutoFit/>
-          </a:bodyPr>
-          <a:lstStyle/>
-          <a:p>
-            <a:pPr algn="l">
-              <a:lnSpc>
-                <a:spcPct val="100000"/>
-              </a:lnSpc>
-            </a:pPr>
-            <a:r>
-              <a:rPr sz="1700" b="1" i="0">
-                <a:solidFill>
-                  <a:srgbClr val="0B1F2A"/>
-                </a:solidFill>
-                <a:latin typeface="Calibri"/>
-              </a:rPr>
-              <a:t>Qualité</a:t>
-            </a:r>
-          </a:p>
-          <a:p>
-            <a:pPr algn="l">
-              <a:lnSpc>
-                <a:spcPct val="100000"/>
-              </a:lnSpc>
-            </a:pPr>
-            <a:r>
-              <a:rPr sz="1350" b="0" i="0">
-                <a:solidFill>
-                  <a:srgbClr val="5B636A"/>
-                </a:solidFill>
-                <a:latin typeface="Calibri"/>
-              </a:rPr>
-              <a:t>aucun aller-retour A→B→A, arrivées au plus tôt, résultat identique d'une exécution à l'autre</a:t>
-            </a:r>
-          </a:p>
-        </p:txBody>
-      </p:sp>
-      <p:sp>
-        <p:nvSpPr>
-          <p:cNvPr id="17" name="Rounded Rectangle 16"/>
-          <p:cNvSpPr/>
-          <p:nvPr/>
-        </p:nvSpPr>
-        <p:spPr>
-          <a:xfrm>
-            <a:off x="6172200" y="4572000"/>
-            <a:ext cx="5440680" cy="1298448"/>
-          </a:xfrm>
-          <a:prstGeom prst="roundRect">
-            <a:avLst>
-              <a:gd name="adj" fmla="val 8000"/>
-            </a:avLst>
-          </a:prstGeom>
-          <a:solidFill>
-            <a:srgbClr val="F3F5F7"/>
-          </a:solidFill>
-          <a:ln>
-            <a:noFill/>
-          </a:ln>
-          <a:effectLst/>
-        </p:spPr>
-        <p:style>
-          <a:lnRef idx="1">
-            <a:schemeClr val="accent1"/>
-          </a:lnRef>
-          <a:fillRef idx="3">
-            <a:schemeClr val="accent1"/>
-          </a:fillRef>
-          <a:effectRef idx="2">
-            <a:schemeClr val="accent1"/>
-          </a:effectRef>
-          <a:fontRef idx="minor">
-            <a:schemeClr val="lt1"/>
-          </a:fontRef>
-        </p:style>
-        <p:txBody>
-          <a:bodyPr rtlCol="0" anchor="ctr" lIns="0" rIns="0"/>
-          <a:lstStyle/>
-          <a:p>
-            <a:pPr algn="ctr"/>
-          </a:p>
-        </p:txBody>
-      </p:sp>
-      <p:sp>
-        <p:nvSpPr>
-          <p:cNvPr id="18" name="TextBox 17"/>
-          <p:cNvSpPr txBox="1"/>
-          <p:nvPr/>
-        </p:nvSpPr>
-        <p:spPr>
-          <a:xfrm>
-            <a:off x="6400800" y="4709160"/>
-            <a:ext cx="5029200" cy="1097280"/>
-          </a:xfrm>
-          <a:prstGeom prst="rect">
-            <a:avLst/>
-          </a:prstGeom>
-          <a:noFill/>
-        </p:spPr>
-        <p:txBody>
-          <a:bodyPr wrap="square" lIns="0" rIns="0" tIns="0" bIns="0" anchor="t">
-            <a:spAutoFit/>
-          </a:bodyPr>
-          <a:lstStyle/>
-          <a:p>
-            <a:pPr algn="l">
-              <a:lnSpc>
-                <a:spcPct val="100000"/>
-              </a:lnSpc>
-            </a:pPr>
-            <a:r>
-              <a:rPr sz="1700" b="1" i="0">
-                <a:solidFill>
-                  <a:srgbClr val="0B1F2A"/>
-                </a:solidFill>
-                <a:latin typeface="Calibri"/>
-              </a:rPr>
-              <a:t>Contre-épreuve</a:t>
-            </a:r>
-          </a:p>
-          <a:p>
-            <a:pPr algn="l">
-              <a:lnSpc>
-                <a:spcPct val="100000"/>
-              </a:lnSpc>
-            </a:pPr>
-            <a:r>
-              <a:rPr sz="1350" b="0" i="0">
-                <a:solidFill>
-                  <a:srgbClr val="5B636A"/>
-                </a:solidFill>
-                <a:latin typeface="Calibri"/>
-              </a:rPr>
-              <a:t>3 solveurs volontairement faux sont détectés par la recherche exhaustive (136, 77 et 101 cas sur 400)</a:t>
-            </a:r>
-          </a:p>
-        </p:txBody>
-      </p:sp>
     </p:spTree>
   </p:cSld>
   <p:clrMapOvr>
@@ -8970,7 +8758,7 @@
                 </a:solidFill>
                 <a:latin typeface="Calibri"/>
               </a:rPr>
-              <a:t>Résultats complets</a:t>
+              <a:t>Comment on sait que c'est juste</a:t>
             </a:r>
           </a:p>
         </p:txBody>
@@ -8983,8 +8771,8 @@
         </p:nvSpPr>
         <p:spPr>
           <a:xfrm>
-            <a:off x="548640" y="6473952"/>
-            <a:ext cx="5486400" cy="274320"/>
+            <a:off x="548640" y="1024128"/>
+            <a:ext cx="9326880" cy="411480"/>
           </a:xfrm>
           <a:prstGeom prst="rect">
             <a:avLst/>
@@ -9003,6 +8791,45 @@
               </a:lnSpc>
             </a:pPr>
             <a:r>
+              <a:rPr sz="1700" b="0" i="0">
+                <a:solidFill>
+                  <a:srgbClr val="5B636A"/>
+                </a:solidFill>
+                <a:latin typeface="Calibri"/>
+              </a:rPr>
+              <a:t>61 tests automatiques, lancés à chaque push par GitHub Actions</a:t>
+            </a:r>
+          </a:p>
+        </p:txBody>
+      </p:sp>
+      <p:sp>
+        <p:nvSpPr>
+          <p:cNvPr id="5" name="TextBox 4"/>
+          <p:cNvSpPr txBox="1"/>
+          <p:nvPr/>
+        </p:nvSpPr>
+        <p:spPr>
+          <a:xfrm>
+            <a:off x="548640" y="6473952"/>
+            <a:ext cx="5486400" cy="274320"/>
+          </a:xfrm>
+          <a:prstGeom prst="rect">
+            <a:avLst/>
+          </a:prstGeom>
+          <a:noFill/>
+        </p:spPr>
+        <p:txBody>
+          <a:bodyPr wrap="square" lIns="0" rIns="0" tIns="0" bIns="0" anchor="t">
+            <a:spAutoFit/>
+          </a:bodyPr>
+          <a:lstStyle/>
+          <a:p>
+            <a:pPr algn="l">
+              <a:lnSpc>
+                <a:spcPct val="100000"/>
+              </a:lnSpc>
+            </a:pPr>
+            <a:r>
               <a:rPr sz="1000" b="0" i="0">
                 <a:solidFill>
                   <a:srgbClr val="5B636A"/>
@@ -9016,7 +8843,7 @@
       </p:sp>
       <p:sp>
         <p:nvSpPr>
-          <p:cNvPr id="5" name="TextBox 4"/>
+          <p:cNvPr id="6" name="TextBox 5"/>
           <p:cNvSpPr txBox="1"/>
           <p:nvPr/>
         </p:nvSpPr>
@@ -9053,30 +8880,612 @@
           </a:p>
         </p:txBody>
       </p:sp>
-      <p:pic>
-        <p:nvPicPr>
-          <p:cNvPr id="6" name="Picture 5" descr="resultats.png"/>
-          <p:cNvPicPr>
-            <a:picLocks noChangeAspect="1"/>
-          </p:cNvPicPr>
-          <p:nvPr/>
-        </p:nvPicPr>
-        <p:blipFill>
-          <a:blip r:embed="rId2"/>
-          <a:stretch>
-            <a:fillRect/>
-          </a:stretch>
-        </p:blipFill>
-        <p:spPr>
-          <a:xfrm>
-            <a:off x="1368877" y="1143000"/>
-            <a:ext cx="9423765" cy="5303520"/>
+      <p:sp>
+        <p:nvSpPr>
+          <p:cNvPr id="7" name="Rounded Rectangle 6"/>
+          <p:cNvSpPr/>
+          <p:nvPr/>
+        </p:nvSpPr>
+        <p:spPr>
+          <a:xfrm>
+            <a:off x="548640" y="1645920"/>
+            <a:ext cx="5440680" cy="1298448"/>
+          </a:xfrm>
+          <a:prstGeom prst="roundRect">
+            <a:avLst>
+              <a:gd name="adj" fmla="val 8000"/>
+            </a:avLst>
+          </a:prstGeom>
+          <a:solidFill>
+            <a:srgbClr val="F3F5F7"/>
+          </a:solidFill>
+          <a:ln>
+            <a:noFill/>
+          </a:ln>
+          <a:effectLst/>
+        </p:spPr>
+        <p:style>
+          <a:lnRef idx="1">
+            <a:schemeClr val="accent1"/>
+          </a:lnRef>
+          <a:fillRef idx="3">
+            <a:schemeClr val="accent1"/>
+          </a:fillRef>
+          <a:effectRef idx="2">
+            <a:schemeClr val="accent1"/>
+          </a:effectRef>
+          <a:fontRef idx="minor">
+            <a:schemeClr val="lt1"/>
+          </a:fontRef>
+        </p:style>
+        <p:txBody>
+          <a:bodyPr rtlCol="0" anchor="ctr" lIns="0" rIns="0"/>
+          <a:lstStyle/>
+          <a:p>
+            <a:pPr algn="ctr"/>
+          </a:p>
+        </p:txBody>
+      </p:sp>
+      <p:sp>
+        <p:nvSpPr>
+          <p:cNvPr id="8" name="TextBox 7"/>
+          <p:cNvSpPr txBox="1"/>
+          <p:nvPr/>
+        </p:nvSpPr>
+        <p:spPr>
+          <a:xfrm>
+            <a:off x="777240" y="1783080"/>
+            <a:ext cx="5029200" cy="1097280"/>
           </a:xfrm>
           <a:prstGeom prst="rect">
             <a:avLst/>
           </a:prstGeom>
-        </p:spPr>
-      </p:pic>
+          <a:noFill/>
+        </p:spPr>
+        <p:txBody>
+          <a:bodyPr wrap="square" lIns="0" rIns="0" tIns="0" bIns="0" anchor="t">
+            <a:spAutoFit/>
+          </a:bodyPr>
+          <a:lstStyle/>
+          <a:p>
+            <a:pPr algn="l">
+              <a:lnSpc>
+                <a:spcPct val="100000"/>
+              </a:lnSpc>
+            </a:pPr>
+            <a:r>
+              <a:rPr sz="1700" b="1" i="0">
+                <a:solidFill>
+                  <a:srgbClr val="0B1F2A"/>
+                </a:solidFill>
+                <a:latin typeface="Calibri"/>
+              </a:rPr>
+              <a:t>Parseur</a:t>
+            </a:r>
+          </a:p>
+          <a:p>
+            <a:pPr algn="l">
+              <a:lnSpc>
+                <a:spcPct val="100000"/>
+              </a:lnSpc>
+            </a:pPr>
+            <a:r>
+              <a:rPr sz="1350" b="0" i="0">
+                <a:solidFill>
+                  <a:srgbClr val="5B636A"/>
+                </a:solidFill>
+                <a:latin typeface="Calibri"/>
+              </a:rPr>
+              <a:t>S1 { 5 }, f=50, F = 100, BOM, CRLF, tabulations, commentaires ; erreurs avec numéro de ligne ; capacités contradictoires</a:t>
+            </a:r>
+          </a:p>
+        </p:txBody>
+      </p:sp>
+      <p:sp>
+        <p:nvSpPr>
+          <p:cNvPr id="9" name="Rounded Rectangle 8"/>
+          <p:cNvSpPr/>
+          <p:nvPr/>
+        </p:nvSpPr>
+        <p:spPr>
+          <a:xfrm>
+            <a:off x="6172200" y="1645920"/>
+            <a:ext cx="5440680" cy="1298448"/>
+          </a:xfrm>
+          <a:prstGeom prst="roundRect">
+            <a:avLst>
+              <a:gd name="adj" fmla="val 8000"/>
+            </a:avLst>
+          </a:prstGeom>
+          <a:solidFill>
+            <a:srgbClr val="F3F5F7"/>
+          </a:solidFill>
+          <a:ln>
+            <a:noFill/>
+          </a:ln>
+          <a:effectLst/>
+        </p:spPr>
+        <p:style>
+          <a:lnRef idx="1">
+            <a:schemeClr val="accent1"/>
+          </a:lnRef>
+          <a:fillRef idx="3">
+            <a:schemeClr val="accent1"/>
+          </a:fillRef>
+          <a:effectRef idx="2">
+            <a:schemeClr val="accent1"/>
+          </a:effectRef>
+          <a:fontRef idx="minor">
+            <a:schemeClr val="lt1"/>
+          </a:fontRef>
+        </p:style>
+        <p:txBody>
+          <a:bodyPr rtlCol="0" anchor="ctr" lIns="0" rIns="0"/>
+          <a:lstStyle/>
+          <a:p>
+            <a:pPr algn="ctr"/>
+          </a:p>
+        </p:txBody>
+      </p:sp>
+      <p:sp>
+        <p:nvSpPr>
+          <p:cNvPr id="10" name="TextBox 9"/>
+          <p:cNvSpPr txBox="1"/>
+          <p:nvPr/>
+        </p:nvSpPr>
+        <p:spPr>
+          <a:xfrm>
+            <a:off x="6400800" y="1783080"/>
+            <a:ext cx="5029200" cy="1097280"/>
+          </a:xfrm>
+          <a:prstGeom prst="rect">
+            <a:avLst/>
+          </a:prstGeom>
+          <a:noFill/>
+        </p:spPr>
+        <p:txBody>
+          <a:bodyPr wrap="square" lIns="0" rIns="0" tIns="0" bIns="0" anchor="t">
+            <a:spAutoFit/>
+          </a:bodyPr>
+          <a:lstStyle/>
+          <a:p>
+            <a:pPr algn="l">
+              <a:lnSpc>
+                <a:spcPct val="100000"/>
+              </a:lnSpc>
+            </a:pPr>
+            <a:r>
+              <a:rPr sz="1700" b="1" i="0">
+                <a:solidFill>
+                  <a:srgbClr val="0B1F2A"/>
+                </a:solidFill>
+                <a:latin typeface="Calibri"/>
+              </a:rPr>
+              <a:t>Règles</a:t>
+            </a:r>
+          </a:p>
+          <a:p>
+            <a:pPr algn="l">
+              <a:lnSpc>
+                <a:spcPct val="100000"/>
+              </a:lnSpc>
+            </a:pPr>
+            <a:r>
+              <a:rPr sz="1350" b="0" i="0">
+                <a:solidFill>
+                  <a:srgbClr val="5B636A"/>
+                </a:solidFill>
+                <a:latin typeface="Calibri"/>
+              </a:rPr>
+              <a:t>capacités à chaque instant, tunnels existants, départ Sv, arrivée Sd, Sd absorbant, nombre exact de fourmis</a:t>
+            </a:r>
+          </a:p>
+        </p:txBody>
+      </p:sp>
+      <p:sp>
+        <p:nvSpPr>
+          <p:cNvPr id="11" name="Rounded Rectangle 10"/>
+          <p:cNvSpPr/>
+          <p:nvPr/>
+        </p:nvSpPr>
+        <p:spPr>
+          <a:xfrm>
+            <a:off x="548640" y="3108960"/>
+            <a:ext cx="5440680" cy="1298448"/>
+          </a:xfrm>
+          <a:prstGeom prst="roundRect">
+            <a:avLst>
+              <a:gd name="adj" fmla="val 8000"/>
+            </a:avLst>
+          </a:prstGeom>
+          <a:solidFill>
+            <a:srgbClr val="F3F5F7"/>
+          </a:solidFill>
+          <a:ln>
+            <a:noFill/>
+          </a:ln>
+          <a:effectLst/>
+        </p:spPr>
+        <p:style>
+          <a:lnRef idx="1">
+            <a:schemeClr val="accent1"/>
+          </a:lnRef>
+          <a:fillRef idx="3">
+            <a:schemeClr val="accent1"/>
+          </a:fillRef>
+          <a:effectRef idx="2">
+            <a:schemeClr val="accent1"/>
+          </a:effectRef>
+          <a:fontRef idx="minor">
+            <a:schemeClr val="lt1"/>
+          </a:fontRef>
+        </p:style>
+        <p:txBody>
+          <a:bodyPr rtlCol="0" anchor="ctr" lIns="0" rIns="0"/>
+          <a:lstStyle/>
+          <a:p>
+            <a:pPr algn="ctr"/>
+          </a:p>
+        </p:txBody>
+      </p:sp>
+      <p:sp>
+        <p:nvSpPr>
+          <p:cNvPr id="12" name="TextBox 11"/>
+          <p:cNvSpPr txBox="1"/>
+          <p:nvPr/>
+        </p:nvSpPr>
+        <p:spPr>
+          <a:xfrm>
+            <a:off x="777240" y="3246120"/>
+            <a:ext cx="5029200" cy="1097280"/>
+          </a:xfrm>
+          <a:prstGeom prst="rect">
+            <a:avLst/>
+          </a:prstGeom>
+          <a:noFill/>
+        </p:spPr>
+        <p:txBody>
+          <a:bodyPr wrap="square" lIns="0" rIns="0" tIns="0" bIns="0" anchor="t">
+            <a:spAutoFit/>
+          </a:bodyPr>
+          <a:lstStyle/>
+          <a:p>
+            <a:pPr algn="l">
+              <a:lnSpc>
+                <a:spcPct val="100000"/>
+              </a:lnSpc>
+            </a:pPr>
+            <a:r>
+              <a:rPr sz="1700" b="1" i="0">
+                <a:solidFill>
+                  <a:srgbClr val="0B1F2A"/>
+                </a:solidFill>
+                <a:latin typeface="Calibri"/>
+              </a:rPr>
+              <a:t>Topologies</a:t>
+            </a:r>
+          </a:p>
+          <a:p>
+            <a:pPr algn="l">
+              <a:lnSpc>
+                <a:spcPct val="100000"/>
+              </a:lnSpc>
+            </a:pPr>
+            <a:r>
+              <a:rPr sz="1350" b="0" i="0">
+                <a:solidFill>
+                  <a:srgbClr val="5B636A"/>
+                </a:solidFill>
+                <a:latin typeface="Calibri"/>
+              </a:rPr>
+              <a:t>cul-de-sac, cycle, tunnel direct Sv–Sd, grosse capacité, goulot, F = 100</a:t>
+            </a:r>
+          </a:p>
+        </p:txBody>
+      </p:sp>
+      <p:sp>
+        <p:nvSpPr>
+          <p:cNvPr id="13" name="Rounded Rectangle 12"/>
+          <p:cNvSpPr/>
+          <p:nvPr/>
+        </p:nvSpPr>
+        <p:spPr>
+          <a:xfrm>
+            <a:off x="6172200" y="3108960"/>
+            <a:ext cx="5440680" cy="1298448"/>
+          </a:xfrm>
+          <a:prstGeom prst="roundRect">
+            <a:avLst>
+              <a:gd name="adj" fmla="val 8000"/>
+            </a:avLst>
+          </a:prstGeom>
+          <a:solidFill>
+            <a:srgbClr val="F3F5F7"/>
+          </a:solidFill>
+          <a:ln>
+            <a:noFill/>
+          </a:ln>
+          <a:effectLst/>
+        </p:spPr>
+        <p:style>
+          <a:lnRef idx="1">
+            <a:schemeClr val="accent1"/>
+          </a:lnRef>
+          <a:fillRef idx="3">
+            <a:schemeClr val="accent1"/>
+          </a:fillRef>
+          <a:effectRef idx="2">
+            <a:schemeClr val="accent1"/>
+          </a:effectRef>
+          <a:fontRef idx="minor">
+            <a:schemeClr val="lt1"/>
+          </a:fontRef>
+        </p:style>
+        <p:txBody>
+          <a:bodyPr rtlCol="0" anchor="ctr" lIns="0" rIns="0"/>
+          <a:lstStyle/>
+          <a:p>
+            <a:pPr algn="ctr"/>
+          </a:p>
+        </p:txBody>
+      </p:sp>
+      <p:sp>
+        <p:nvSpPr>
+          <p:cNvPr id="14" name="TextBox 13"/>
+          <p:cNvSpPr txBox="1"/>
+          <p:nvPr/>
+        </p:nvSpPr>
+        <p:spPr>
+          <a:xfrm>
+            <a:off x="6400800" y="3246120"/>
+            <a:ext cx="5029200" cy="1097280"/>
+          </a:xfrm>
+          <a:prstGeom prst="rect">
+            <a:avLst/>
+          </a:prstGeom>
+          <a:noFill/>
+        </p:spPr>
+        <p:txBody>
+          <a:bodyPr wrap="square" lIns="0" rIns="0" tIns="0" bIns="0" anchor="t">
+            <a:spAutoFit/>
+          </a:bodyPr>
+          <a:lstStyle/>
+          <a:p>
+            <a:pPr algn="l">
+              <a:lnSpc>
+                <a:spcPct val="100000"/>
+              </a:lnSpc>
+            </a:pPr>
+            <a:r>
+              <a:rPr sz="1700" b="1" i="0">
+                <a:solidFill>
+                  <a:srgbClr val="0B1F2A"/>
+                </a:solidFill>
+                <a:latin typeface="Calibri"/>
+              </a:rPr>
+              <a:t>Optimalité</a:t>
+            </a:r>
+          </a:p>
+          <a:p>
+            <a:pPr algn="l">
+              <a:lnSpc>
+                <a:spcPct val="100000"/>
+              </a:lnSpc>
+            </a:pPr>
+            <a:r>
+              <a:rPr sz="1350" b="0" i="0">
+                <a:solidFill>
+                  <a:srgbClr val="5B636A"/>
+                </a:solidFill>
+                <a:latin typeface="Calibri"/>
+              </a:rPr>
+              <a:t>max-flow insuffisant à T − 1 ; 400 graphes aléatoires comparés à une recherche exhaustive (BFS sur les états)</a:t>
+            </a:r>
+          </a:p>
+        </p:txBody>
+      </p:sp>
+      <p:sp>
+        <p:nvSpPr>
+          <p:cNvPr id="15" name="Rounded Rectangle 14"/>
+          <p:cNvSpPr/>
+          <p:nvPr/>
+        </p:nvSpPr>
+        <p:spPr>
+          <a:xfrm>
+            <a:off x="548640" y="4572000"/>
+            <a:ext cx="5440680" cy="1298448"/>
+          </a:xfrm>
+          <a:prstGeom prst="roundRect">
+            <a:avLst>
+              <a:gd name="adj" fmla="val 8000"/>
+            </a:avLst>
+          </a:prstGeom>
+          <a:solidFill>
+            <a:srgbClr val="F3F5F7"/>
+          </a:solidFill>
+          <a:ln>
+            <a:noFill/>
+          </a:ln>
+          <a:effectLst/>
+        </p:spPr>
+        <p:style>
+          <a:lnRef idx="1">
+            <a:schemeClr val="accent1"/>
+          </a:lnRef>
+          <a:fillRef idx="3">
+            <a:schemeClr val="accent1"/>
+          </a:fillRef>
+          <a:effectRef idx="2">
+            <a:schemeClr val="accent1"/>
+          </a:effectRef>
+          <a:fontRef idx="minor">
+            <a:schemeClr val="lt1"/>
+          </a:fontRef>
+        </p:style>
+        <p:txBody>
+          <a:bodyPr rtlCol="0" anchor="ctr" lIns="0" rIns="0"/>
+          <a:lstStyle/>
+          <a:p>
+            <a:pPr algn="ctr"/>
+          </a:p>
+        </p:txBody>
+      </p:sp>
+      <p:sp>
+        <p:nvSpPr>
+          <p:cNvPr id="16" name="TextBox 15"/>
+          <p:cNvSpPr txBox="1"/>
+          <p:nvPr/>
+        </p:nvSpPr>
+        <p:spPr>
+          <a:xfrm>
+            <a:off x="777240" y="4709160"/>
+            <a:ext cx="5029200" cy="1097280"/>
+          </a:xfrm>
+          <a:prstGeom prst="rect">
+            <a:avLst/>
+          </a:prstGeom>
+          <a:noFill/>
+        </p:spPr>
+        <p:txBody>
+          <a:bodyPr wrap="square" lIns="0" rIns="0" tIns="0" bIns="0" anchor="t">
+            <a:spAutoFit/>
+          </a:bodyPr>
+          <a:lstStyle/>
+          <a:p>
+            <a:pPr algn="l">
+              <a:lnSpc>
+                <a:spcPct val="100000"/>
+              </a:lnSpc>
+            </a:pPr>
+            <a:r>
+              <a:rPr sz="1700" b="1" i="0">
+                <a:solidFill>
+                  <a:srgbClr val="0B1F2A"/>
+                </a:solidFill>
+                <a:latin typeface="Calibri"/>
+              </a:rPr>
+              <a:t>Qualité</a:t>
+            </a:r>
+          </a:p>
+          <a:p>
+            <a:pPr algn="l">
+              <a:lnSpc>
+                <a:spcPct val="100000"/>
+              </a:lnSpc>
+            </a:pPr>
+            <a:r>
+              <a:rPr sz="1350" b="0" i="0">
+                <a:solidFill>
+                  <a:srgbClr val="5B636A"/>
+                </a:solidFill>
+                <a:latin typeface="Calibri"/>
+              </a:rPr>
+              <a:t>aucun aller-retour A→B→A, arrivées au plus tôt, résultat identique d'une exécution à l'autre</a:t>
+            </a:r>
+          </a:p>
+        </p:txBody>
+      </p:sp>
+      <p:sp>
+        <p:nvSpPr>
+          <p:cNvPr id="17" name="Rounded Rectangle 16"/>
+          <p:cNvSpPr/>
+          <p:nvPr/>
+        </p:nvSpPr>
+        <p:spPr>
+          <a:xfrm>
+            <a:off x="6172200" y="4572000"/>
+            <a:ext cx="5440680" cy="1298448"/>
+          </a:xfrm>
+          <a:prstGeom prst="roundRect">
+            <a:avLst>
+              <a:gd name="adj" fmla="val 8000"/>
+            </a:avLst>
+          </a:prstGeom>
+          <a:solidFill>
+            <a:srgbClr val="F3F5F7"/>
+          </a:solidFill>
+          <a:ln>
+            <a:noFill/>
+          </a:ln>
+          <a:effectLst/>
+        </p:spPr>
+        <p:style>
+          <a:lnRef idx="1">
+            <a:schemeClr val="accent1"/>
+          </a:lnRef>
+          <a:fillRef idx="3">
+            <a:schemeClr val="accent1"/>
+          </a:fillRef>
+          <a:effectRef idx="2">
+            <a:schemeClr val="accent1"/>
+          </a:effectRef>
+          <a:fontRef idx="minor">
+            <a:schemeClr val="lt1"/>
+          </a:fontRef>
+        </p:style>
+        <p:txBody>
+          <a:bodyPr rtlCol="0" anchor="ctr" lIns="0" rIns="0"/>
+          <a:lstStyle/>
+          <a:p>
+            <a:pPr algn="ctr"/>
+          </a:p>
+        </p:txBody>
+      </p:sp>
+      <p:sp>
+        <p:nvSpPr>
+          <p:cNvPr id="18" name="TextBox 17"/>
+          <p:cNvSpPr txBox="1"/>
+          <p:nvPr/>
+        </p:nvSpPr>
+        <p:spPr>
+          <a:xfrm>
+            <a:off x="6400800" y="4709160"/>
+            <a:ext cx="5029200" cy="1097280"/>
+          </a:xfrm>
+          <a:prstGeom prst="rect">
+            <a:avLst/>
+          </a:prstGeom>
+          <a:noFill/>
+        </p:spPr>
+        <p:txBody>
+          <a:bodyPr wrap="square" lIns="0" rIns="0" tIns="0" bIns="0" anchor="t">
+            <a:spAutoFit/>
+          </a:bodyPr>
+          <a:lstStyle/>
+          <a:p>
+            <a:pPr algn="l">
+              <a:lnSpc>
+                <a:spcPct val="100000"/>
+              </a:lnSpc>
+            </a:pPr>
+            <a:r>
+              <a:rPr sz="1700" b="1" i="0">
+                <a:solidFill>
+                  <a:srgbClr val="0B1F2A"/>
+                </a:solidFill>
+                <a:latin typeface="Calibri"/>
+              </a:rPr>
+              <a:t>Contre-épreuve</a:t>
+            </a:r>
+          </a:p>
+          <a:p>
+            <a:pPr algn="l">
+              <a:lnSpc>
+                <a:spcPct val="100000"/>
+              </a:lnSpc>
+            </a:pPr>
+            <a:r>
+              <a:rPr sz="1350" b="0" i="0">
+                <a:solidFill>
+                  <a:srgbClr val="5B636A"/>
+                </a:solidFill>
+                <a:latin typeface="Calibri"/>
+              </a:rPr>
+              <a:t>3 solveurs volontairement faux sont détectés par la recherche exhaustive (136, 77 et 101 cas sur 400)</a:t>
+            </a:r>
+          </a:p>
+        </p:txBody>
+      </p:sp>
     </p:spTree>
   </p:cSld>
   <p:clrMapOvr>
@@ -9192,7 +9601,7 @@
                 </a:solidFill>
                 <a:latin typeface="Calibri"/>
               </a:rPr>
-              <a:t>Si le GIF ne s'anime pas : les étapes clés</a:t>
+              <a:t>Résultats complets</a:t>
             </a:r>
           </a:p>
         </p:txBody>
@@ -9205,8 +9614,8 @@
         </p:nvSpPr>
         <p:spPr>
           <a:xfrm>
-            <a:off x="548640" y="1024128"/>
-            <a:ext cx="9326880" cy="411480"/>
+            <a:off x="548640" y="6473952"/>
+            <a:ext cx="5486400" cy="274320"/>
           </a:xfrm>
           <a:prstGeom prst="rect">
             <a:avLst/>
@@ -9225,13 +9634,13 @@
               </a:lnSpc>
             </a:pPr>
             <a:r>
-              <a:rPr sz="1700" b="0" i="0">
+              <a:rPr sz="1000" b="0" i="0">
                 <a:solidFill>
                   <a:srgbClr val="5B636A"/>
                 </a:solidFill>
                 <a:latin typeface="Calibri"/>
               </a:rPr>
-              <a:t>fourmiliere_cinq · mêmes positions sur chaque image</a:t>
+              <a:t>Une vie de fourmi · Romain · Lisa · Yannis</a:t>
             </a:r>
           </a:p>
         </p:txBody>
@@ -9244,8 +9653,152 @@
         </p:nvSpPr>
         <p:spPr>
           <a:xfrm>
-            <a:off x="548640" y="6473952"/>
-            <a:ext cx="5486400" cy="274320"/>
+            <a:off x="11185855" y="6473952"/>
+            <a:ext cx="457200" cy="274320"/>
+          </a:xfrm>
+          <a:prstGeom prst="rect">
+            <a:avLst/>
+          </a:prstGeom>
+          <a:noFill/>
+        </p:spPr>
+        <p:txBody>
+          <a:bodyPr wrap="square" lIns="0" rIns="0" tIns="0" bIns="0" anchor="t">
+            <a:spAutoFit/>
+          </a:bodyPr>
+          <a:lstStyle/>
+          <a:p>
+            <a:pPr algn="r">
+              <a:lnSpc>
+                <a:spcPct val="100000"/>
+              </a:lnSpc>
+            </a:pPr>
+            <a:r>
+              <a:rPr sz="1000" b="0" i="0">
+                <a:solidFill>
+                  <a:srgbClr val="5B636A"/>
+                </a:solidFill>
+                <a:latin typeface="Calibri"/>
+              </a:rPr>
+              <a:t>15</a:t>
+            </a:r>
+          </a:p>
+        </p:txBody>
+      </p:sp>
+      <p:pic>
+        <p:nvPicPr>
+          <p:cNvPr id="6" name="Picture 5" descr="resultats.png"/>
+          <p:cNvPicPr>
+            <a:picLocks noChangeAspect="1"/>
+          </p:cNvPicPr>
+          <p:nvPr/>
+        </p:nvPicPr>
+        <p:blipFill>
+          <a:blip r:embed="rId2"/>
+          <a:stretch>
+            <a:fillRect/>
+          </a:stretch>
+        </p:blipFill>
+        <p:spPr>
+          <a:xfrm>
+            <a:off x="1368877" y="1143000"/>
+            <a:ext cx="9423765" cy="5303520"/>
+          </a:xfrm>
+          <a:prstGeom prst="rect">
+            <a:avLst/>
+          </a:prstGeom>
+        </p:spPr>
+      </p:pic>
+    </p:spTree>
+  </p:cSld>
+  <p:clrMapOvr>
+    <a:masterClrMapping/>
+  </p:clrMapOvr>
+</p:sld>
+</file>
+
+<file path=ppt/slides/slide16.xml><?xml version="1.0" encoding="utf-8"?>
+<p:sld xmlns:a="http://schemas.openxmlformats.org/drawingml/2006/main" xmlns:p="http://schemas.openxmlformats.org/presentationml/2006/main" xmlns:r="http://schemas.openxmlformats.org/officeDocument/2006/relationships">
+  <p:cSld>
+    <p:bg>
+      <p:bgPr>
+        <a:solidFill>
+          <a:srgbClr val="FFFFFF"/>
+        </a:solidFill>
+        <a:effectLst/>
+      </p:bgPr>
+    </p:bg>
+    <p:spTree>
+      <p:nvGrpSpPr>
+        <p:cNvPr id="1" name=""/>
+        <p:cNvGrpSpPr/>
+        <p:nvPr/>
+      </p:nvGrpSpPr>
+      <p:grpSpPr/>
+      <p:sp>
+        <p:nvSpPr>
+          <p:cNvPr id="2" name="Rounded Rectangle 1"/>
+          <p:cNvSpPr/>
+          <p:nvPr/>
+        </p:nvSpPr>
+        <p:spPr>
+          <a:xfrm>
+            <a:off x="10317176" y="384048"/>
+            <a:ext cx="1463040" cy="384048"/>
+          </a:xfrm>
+          <a:prstGeom prst="roundRect">
+            <a:avLst>
+              <a:gd name="adj" fmla="val 50000"/>
+            </a:avLst>
+          </a:prstGeom>
+          <a:solidFill>
+            <a:srgbClr val="F3F5F7"/>
+          </a:solidFill>
+          <a:ln>
+            <a:noFill/>
+          </a:ln>
+          <a:effectLst/>
+        </p:spPr>
+        <p:style>
+          <a:lnRef idx="1">
+            <a:schemeClr val="accent1"/>
+          </a:lnRef>
+          <a:fillRef idx="3">
+            <a:schemeClr val="accent1"/>
+          </a:fillRef>
+          <a:effectRef idx="2">
+            <a:schemeClr val="accent1"/>
+          </a:effectRef>
+          <a:fontRef idx="minor">
+            <a:schemeClr val="lt1"/>
+          </a:fontRef>
+        </p:style>
+        <p:txBody>
+          <a:bodyPr rtlCol="0" anchor="ctr" lIns="0" rIns="0"/>
+          <a:lstStyle/>
+          <a:p>
+            <a:pPr algn="ctr"/>
+            <a:r>
+              <a:rPr sz="1300" b="1">
+                <a:solidFill>
+                  <a:srgbClr val="5B636A"/>
+                </a:solidFill>
+                <a:latin typeface="Calibri"/>
+              </a:rPr>
+              <a:t>ANNEXE</a:t>
+            </a:r>
+          </a:p>
+        </p:txBody>
+      </p:sp>
+      <p:sp>
+        <p:nvSpPr>
+          <p:cNvPr id="3" name="TextBox 2"/>
+          <p:cNvSpPr txBox="1"/>
+          <p:nvPr/>
+        </p:nvSpPr>
+        <p:spPr>
+          <a:xfrm>
+            <a:off x="548640" y="347472"/>
+            <a:ext cx="9326880" cy="731520"/>
           </a:xfrm>
           <a:prstGeom prst="rect">
             <a:avLst/>
@@ -9264,6 +9817,84 @@
               </a:lnSpc>
             </a:pPr>
             <a:r>
+              <a:rPr sz="3000" b="1" i="0">
+                <a:solidFill>
+                  <a:srgbClr val="0B1F2A"/>
+                </a:solidFill>
+                <a:latin typeface="Calibri"/>
+              </a:rPr>
+              <a:t>Si le GIF ne s'anime pas : les étapes clés</a:t>
+            </a:r>
+          </a:p>
+        </p:txBody>
+      </p:sp>
+      <p:sp>
+        <p:nvSpPr>
+          <p:cNvPr id="4" name="TextBox 3"/>
+          <p:cNvSpPr txBox="1"/>
+          <p:nvPr/>
+        </p:nvSpPr>
+        <p:spPr>
+          <a:xfrm>
+            <a:off x="548640" y="1024128"/>
+            <a:ext cx="9326880" cy="411480"/>
+          </a:xfrm>
+          <a:prstGeom prst="rect">
+            <a:avLst/>
+          </a:prstGeom>
+          <a:noFill/>
+        </p:spPr>
+        <p:txBody>
+          <a:bodyPr wrap="square" lIns="0" rIns="0" tIns="0" bIns="0" anchor="t">
+            <a:spAutoFit/>
+          </a:bodyPr>
+          <a:lstStyle/>
+          <a:p>
+            <a:pPr algn="l">
+              <a:lnSpc>
+                <a:spcPct val="100000"/>
+              </a:lnSpc>
+            </a:pPr>
+            <a:r>
+              <a:rPr sz="1700" b="0" i="0">
+                <a:solidFill>
+                  <a:srgbClr val="5B636A"/>
+                </a:solidFill>
+                <a:latin typeface="Calibri"/>
+              </a:rPr>
+              <a:t>fourmiliere_cinq · mêmes positions sur chaque image</a:t>
+            </a:r>
+          </a:p>
+        </p:txBody>
+      </p:sp>
+      <p:sp>
+        <p:nvSpPr>
+          <p:cNvPr id="5" name="TextBox 4"/>
+          <p:cNvSpPr txBox="1"/>
+          <p:nvPr/>
+        </p:nvSpPr>
+        <p:spPr>
+          <a:xfrm>
+            <a:off x="548640" y="6473952"/>
+            <a:ext cx="5486400" cy="274320"/>
+          </a:xfrm>
+          <a:prstGeom prst="rect">
+            <a:avLst/>
+          </a:prstGeom>
+          <a:noFill/>
+        </p:spPr>
+        <p:txBody>
+          <a:bodyPr wrap="square" lIns="0" rIns="0" tIns="0" bIns="0" anchor="t">
+            <a:spAutoFit/>
+          </a:bodyPr>
+          <a:lstStyle/>
+          <a:p>
+            <a:pPr algn="l">
+              <a:lnSpc>
+                <a:spcPct val="100000"/>
+              </a:lnSpc>
+            </a:pPr>
+            <a:r>
               <a:rPr sz="1000" b="0" i="0">
                 <a:solidFill>
                   <a:srgbClr val="5B636A"/>
@@ -9309,7 +9940,7 @@
                 </a:solidFill>
                 <a:latin typeface="Calibri"/>
               </a:rPr>
-              <a:t>15</a:t>
+              <a:t>16</a:t>
             </a:r>
           </a:p>
         </p:txBody>
@@ -11236,7 +11867,7 @@
               </a:lnSpc>
             </a:pPr>
             <a:r>
-              <a:rPr sz="1200" b="1" i="0">
+              <a:rPr sz="1400" b="1" i="0">
                 <a:solidFill>
                   <a:srgbClr val="0B1F2A"/>
                 </a:solidFill>
@@ -11245,49 +11876,31 @@
               <a:t>BFS</a:t>
             </a:r>
             <a:r>
-              <a:rPr sz="1200" b="0" i="0">
+              <a:rPr sz="1400" b="0" i="0">
                 <a:solidFill>
                   <a:srgbClr val="5B636A"/>
                 </a:solidFill>
                 <a:latin typeface="Calibri"/>
               </a:rPr>
-              <a:t> = distance minimale  ·  </a:t>
-            </a:r>
-            <a:r>
-              <a:rPr sz="1200" b="1" i="0">
+              <a:t> donne la borne minimale ; le </a:t>
+            </a:r>
+            <a:r>
+              <a:rPr sz="1400" b="1" i="0">
                 <a:solidFill>
                   <a:srgbClr val="0B1F2A"/>
                 </a:solidFill>
                 <a:latin typeface="Calibri"/>
               </a:rPr>
-              <a:t>Edmonds-Karp</a:t>
-            </a:r>
-            <a:r>
-              <a:rPr sz="1200" b="0" i="0">
+              <a:t>max-flow</a:t>
+            </a:r>
+            <a:r>
+              <a:rPr sz="1400" b="0" i="0">
                 <a:solidFill>
                   <a:srgbClr val="5B636A"/>
                 </a:solidFill>
                 <a:latin typeface="Calibri"/>
               </a:rPr>
-              <a:t> = max-flow (BFS dans le graphe résiduel)  ·  </a:t>
-            </a:r>
-            <a:r>
-              <a:rPr sz="1200" b="1" i="0">
-                <a:solidFill>
-                  <a:srgbClr val="0B1F2A"/>
-                </a:solidFill>
-                <a:latin typeface="Calibri"/>
-              </a:rPr>
-              <a:t>DFS</a:t>
-            </a:r>
-            <a:r>
-              <a:rPr sz="1200" b="0" i="0">
-                <a:solidFill>
-                  <a:srgbClr val="5B636A"/>
-                </a:solidFill>
-                <a:latin typeface="Calibri"/>
-              </a:rPr>
-              <a:t> ne garantit pas le minimum</a:t>
+              <a:t> organise ensuite toute la colonie.</a:t>
             </a:r>
           </a:p>
         </p:txBody>
@@ -13956,7 +14569,7 @@
                 </a:solidFill>
                 <a:latin typeface="Calibri"/>
               </a:rPr>
-              <a:t>56</a:t>
+              <a:t>61</a:t>
             </a:r>
           </a:p>
         </p:txBody>
@@ -15714,7 +16327,7 @@
                 </a:solidFill>
                 <a:latin typeface="Calibri"/>
               </a:rPr>
-              <a:t>56 tests : parseur, solveur, officiels, BFS exhaustif</a:t>
+              <a:t>61 tests : parseur, solveur, officiels, BFS exhaustif</a:t>
             </a:r>
           </a:p>
         </p:txBody>
@@ -15889,7 +16502,7 @@
                 </a:solidFill>
                 <a:latin typeface="Calibri"/>
               </a:rPr>
-              <a:t>BFS, DFS, Dijkstra, Floyd-Warshall : lequel et pourquoi ?</a:t>
+              <a:t>Pourquoi pas simplement BFS ou Dijkstra ?</a:t>
             </a:r>
           </a:p>
         </p:txBody>
@@ -15928,7 +16541,7 @@
                 </a:solidFill>
                 <a:latin typeface="Calibri"/>
               </a:rPr>
-              <a:t>On n'ajoute pas d'algorithme pour faire joli : chacun a un rôle ou une raison d'être absent</a:t>
+              <a:t>Contre-exemple : 3 fourmis, capacité 1, un chemin de longueur 2 et un de longueur 3</a:t>
             </a:r>
           </a:p>
         </p:txBody>
@@ -16011,530 +16624,372 @@
           </a:p>
         </p:txBody>
       </p:sp>
-      <p:graphicFrame>
-        <p:nvGraphicFramePr>
-          <p:cNvPr id="7" name="Table 6"/>
-          <p:cNvGraphicFramePr>
-            <a:graphicFrameLocks noGrp="1"/>
-          </p:cNvGraphicFramePr>
-          <p:nvPr/>
-        </p:nvGraphicFramePr>
-        <p:xfrm>
-          <a:off x="548640" y="1600200"/>
-          <a:ext cx="11064240" cy="3968496"/>
-        </p:xfrm>
-        <a:graphic>
-          <a:graphicData uri="http://schemas.openxmlformats.org/drawingml/2006/table">
-            <a:tbl>
-              <a:tblPr firstRow="1" bandRow="1">
-                <a:tableStyleId>{5C22544A-7EE6-4342-B048-85BDC9FD1C3A}</a:tableStyleId>
-              </a:tblPr>
-              <a:tblGrid>
-                <a:gridCol w="2743200"/>
-                <a:gridCol w="3657600"/>
-                <a:gridCol w="4663440"/>
-              </a:tblGrid>
-              <a:tr h="566928">
-                <a:tc>
-                  <a:txBody>
-                    <a:bodyPr wrap="square"/>
-                    <a:lstStyle/>
-                    <a:p>
-                      <a:pPr algn="l"/>
-                      <a:r>
-                        <a:rPr sz="1400" b="1">
-                          <a:solidFill>
-                            <a:srgbClr val="FFFFFF"/>
-                          </a:solidFill>
-                          <a:latin typeface="Calibri"/>
-                        </a:rPr>
-                        <a:t>Algorithme</a:t>
-                      </a:r>
-                    </a:p>
-                  </a:txBody>
-                  <a:tcPr marL="91440" marR="91440" marT="27432" marB="27432" anchor="ctr">
-                    <a:solidFill>
-                      <a:srgbClr val="0B1F2A"/>
-                    </a:solidFill>
-                  </a:tcPr>
-                </a:tc>
-                <a:tc>
-                  <a:txBody>
-                    <a:bodyPr wrap="square"/>
-                    <a:lstStyle/>
-                    <a:p>
-                      <a:pPr algn="l"/>
-                      <a:r>
-                        <a:rPr sz="1400" b="1">
-                          <a:solidFill>
-                            <a:srgbClr val="FFFFFF"/>
-                          </a:solidFill>
-                          <a:latin typeface="Calibri"/>
-                        </a:rPr>
-                        <a:t>Ce qu'il sait faire</a:t>
-                      </a:r>
-                    </a:p>
-                  </a:txBody>
-                  <a:tcPr marL="91440" marR="91440" marT="27432" marB="27432" anchor="ctr">
-                    <a:solidFill>
-                      <a:srgbClr val="0B1F2A"/>
-                    </a:solidFill>
-                  </a:tcPr>
-                </a:tc>
-                <a:tc>
-                  <a:txBody>
-                    <a:bodyPr wrap="square"/>
-                    <a:lstStyle/>
-                    <a:p>
-                      <a:pPr algn="l"/>
-                      <a:r>
-                        <a:rPr sz="1400" b="1">
-                          <a:solidFill>
-                            <a:srgbClr val="FFFFFF"/>
-                          </a:solidFill>
-                          <a:latin typeface="Calibri"/>
-                        </a:rPr>
-                        <a:t>Dans notre projet</a:t>
-                      </a:r>
-                    </a:p>
-                  </a:txBody>
-                  <a:tcPr marL="91440" marR="91440" marT="27432" marB="27432" anchor="ctr">
-                    <a:solidFill>
-                      <a:srgbClr val="0B1F2A"/>
-                    </a:solidFill>
-                  </a:tcPr>
-                </a:tc>
-              </a:tr>
-              <a:tr h="566928">
-                <a:tc>
-                  <a:txBody>
-                    <a:bodyPr wrap="square"/>
-                    <a:lstStyle/>
-                    <a:p>
-                      <a:pPr algn="l"/>
-                      <a:r>
-                        <a:rPr sz="1400" b="0">
-                          <a:solidFill>
-                            <a:srgbClr val="0B1F2A"/>
-                          </a:solidFill>
-                          <a:latin typeface="Calibri"/>
-                        </a:rPr>
-                        <a:t>BFS (parcours en largeur)</a:t>
-                      </a:r>
-                    </a:p>
-                  </a:txBody>
-                  <a:tcPr marL="91440" marR="91440" marT="27432" marB="27432" anchor="ctr">
-                    <a:solidFill>
-                      <a:srgbClr val="FDE9E0"/>
-                    </a:solidFill>
-                  </a:tcPr>
-                </a:tc>
-                <a:tc>
-                  <a:txBody>
-                    <a:bodyPr wrap="square"/>
-                    <a:lstStyle/>
-                    <a:p>
-                      <a:pPr algn="l"/>
-                      <a:r>
-                        <a:rPr sz="1400" b="0">
-                          <a:solidFill>
-                            <a:srgbClr val="0B1F2A"/>
-                          </a:solidFill>
-                          <a:latin typeface="Calibri"/>
-                        </a:rPr>
-                        <a:t>plus court chemin dans un graphe non pondéré</a:t>
-                      </a:r>
-                    </a:p>
-                  </a:txBody>
-                  <a:tcPr marL="91440" marR="91440" marT="27432" marB="27432" anchor="ctr">
-                    <a:solidFill>
-                      <a:srgbClr val="FDE9E0"/>
-                    </a:solidFill>
-                  </a:tcPr>
-                </a:tc>
-                <a:tc>
-                  <a:txBody>
-                    <a:bodyPr wrap="square"/>
-                    <a:lstStyle/>
-                    <a:p>
-                      <a:pPr algn="l"/>
-                      <a:r>
-                        <a:rPr sz="1400" b="1">
-                          <a:solidFill>
-                            <a:srgbClr val="0B1F2A"/>
-                          </a:solidFill>
-                          <a:latin typeface="Calibri"/>
-                        </a:rPr>
-                        <a:t>UTILISÉ : borne basse d (ants.bfs_distances) et dans Edmonds-Karp</a:t>
-                      </a:r>
-                    </a:p>
-                  </a:txBody>
-                  <a:tcPr marL="91440" marR="91440" marT="27432" marB="27432" anchor="ctr">
-                    <a:solidFill>
-                      <a:srgbClr val="FDE9E0"/>
-                    </a:solidFill>
-                  </a:tcPr>
-                </a:tc>
-              </a:tr>
-              <a:tr h="566928">
-                <a:tc>
-                  <a:txBody>
-                    <a:bodyPr wrap="square"/>
-                    <a:lstStyle/>
-                    <a:p>
-                      <a:pPr algn="l"/>
-                      <a:r>
-                        <a:rPr sz="1400" b="0">
-                          <a:solidFill>
-                            <a:srgbClr val="0B1F2A"/>
-                          </a:solidFill>
-                          <a:latin typeface="Calibri"/>
-                        </a:rPr>
-                        <a:t>Edmonds-Karp (max-flow)</a:t>
-                      </a:r>
-                    </a:p>
-                  </a:txBody>
-                  <a:tcPr marL="91440" marR="91440" marT="27432" marB="27432" anchor="ctr">
-                    <a:solidFill>
-                      <a:srgbClr val="FDE9E0"/>
-                    </a:solidFill>
-                  </a:tcPr>
-                </a:tc>
-                <a:tc>
-                  <a:txBody>
-                    <a:bodyPr wrap="square"/>
-                    <a:lstStyle/>
-                    <a:p>
-                      <a:pPr algn="l"/>
-                      <a:r>
-                        <a:rPr sz="1400" b="0">
-                          <a:solidFill>
-                            <a:srgbClr val="0B1F2A"/>
-                          </a:solidFill>
-                          <a:latin typeface="Calibri"/>
-                        </a:rPr>
-                        <a:t>flot maximal ; chemins augmentants trouvés par BFS</a:t>
-                      </a:r>
-                    </a:p>
-                  </a:txBody>
-                  <a:tcPr marL="91440" marR="91440" marT="27432" marB="27432" anchor="ctr">
-                    <a:solidFill>
-                      <a:srgbClr val="FDE9E0"/>
-                    </a:solidFill>
-                  </a:tcPr>
-                </a:tc>
-                <a:tc>
-                  <a:txBody>
-                    <a:bodyPr wrap="square"/>
-                    <a:lstStyle/>
-                    <a:p>
-                      <a:pPr algn="l"/>
-                      <a:r>
-                        <a:rPr sz="1400" b="1">
-                          <a:solidFill>
-                            <a:srgbClr val="0B1F2A"/>
-                          </a:solidFill>
-                          <a:latin typeface="Calibri"/>
-                        </a:rPr>
-                        <a:t>UTILISÉ : « F fourmis en T étapes ? » sur le graphe temporel</a:t>
-                      </a:r>
-                    </a:p>
-                  </a:txBody>
-                  <a:tcPr marL="91440" marR="91440" marT="27432" marB="27432" anchor="ctr">
-                    <a:solidFill>
-                      <a:srgbClr val="FDE9E0"/>
-                    </a:solidFill>
-                  </a:tcPr>
-                </a:tc>
-              </a:tr>
-              <a:tr h="566928">
-                <a:tc>
-                  <a:txBody>
-                    <a:bodyPr wrap="square"/>
-                    <a:lstStyle/>
-                    <a:p>
-                      <a:pPr algn="l"/>
-                      <a:r>
-                        <a:rPr sz="1400" b="0">
-                          <a:solidFill>
-                            <a:srgbClr val="0B1F2A"/>
-                          </a:solidFill>
-                          <a:latin typeface="Calibri"/>
-                        </a:rPr>
-                        <a:t>Min-cost flow (simplexe réseau)</a:t>
-                      </a:r>
-                    </a:p>
-                  </a:txBody>
-                  <a:tcPr marL="91440" marR="91440" marT="27432" marB="27432" anchor="ctr">
-                    <a:solidFill>
-                      <a:srgbClr val="FDE9E0"/>
-                    </a:solidFill>
-                  </a:tcPr>
-                </a:tc>
-                <a:tc>
-                  <a:txBody>
-                    <a:bodyPr wrap="square"/>
-                    <a:lstStyle/>
-                    <a:p>
-                      <a:pPr algn="l"/>
-                      <a:r>
-                        <a:rPr sz="1400" b="0">
-                          <a:solidFill>
-                            <a:srgbClr val="0B1F2A"/>
-                          </a:solidFill>
-                          <a:latin typeface="Calibri"/>
-                        </a:rPr>
-                        <a:t>flot de coût minimal</a:t>
-                      </a:r>
-                    </a:p>
-                  </a:txBody>
-                  <a:tcPr marL="91440" marR="91440" marT="27432" marB="27432" anchor="ctr">
-                    <a:solidFill>
-                      <a:srgbClr val="FDE9E0"/>
-                    </a:solidFill>
-                  </a:tcPr>
-                </a:tc>
-                <a:tc>
-                  <a:txBody>
-                    <a:bodyPr wrap="square"/>
-                    <a:lstStyle/>
-                    <a:p>
-                      <a:pPr algn="l"/>
-                      <a:r>
-                        <a:rPr sz="1400" b="1">
-                          <a:solidFill>
-                            <a:srgbClr val="0B1F2A"/>
-                          </a:solidFill>
-                          <a:latin typeface="Calibri"/>
-                        </a:rPr>
-                        <a:t>UTILISÉ : seulement à T fixé, pour des trajets propres</a:t>
-                      </a:r>
-                    </a:p>
-                  </a:txBody>
-                  <a:tcPr marL="91440" marR="91440" marT="27432" marB="27432" anchor="ctr">
-                    <a:solidFill>
-                      <a:srgbClr val="FDE9E0"/>
-                    </a:solidFill>
-                  </a:tcPr>
-                </a:tc>
-              </a:tr>
-              <a:tr h="566928">
-                <a:tc>
-                  <a:txBody>
-                    <a:bodyPr wrap="square"/>
-                    <a:lstStyle/>
-                    <a:p>
-                      <a:pPr algn="l"/>
-                      <a:r>
-                        <a:rPr sz="1400" b="0">
-                          <a:solidFill>
-                            <a:srgbClr val="0B1F2A"/>
-                          </a:solidFill>
-                          <a:latin typeface="Calibri"/>
-                        </a:rPr>
-                        <a:t>DFS (parcours en profondeur)</a:t>
-                      </a:r>
-                    </a:p>
-                  </a:txBody>
-                  <a:tcPr marL="91440" marR="91440" marT="27432" marB="27432" anchor="ctr">
-                    <a:solidFill>
-                      <a:srgbClr val="F3F5F7"/>
-                    </a:solidFill>
-                  </a:tcPr>
-                </a:tc>
-                <a:tc>
-                  <a:txBody>
-                    <a:bodyPr wrap="square"/>
-                    <a:lstStyle/>
-                    <a:p>
-                      <a:pPr algn="l"/>
-                      <a:r>
-                        <a:rPr sz="1400" b="0">
-                          <a:solidFill>
-                            <a:srgbClr val="0B1F2A"/>
-                          </a:solidFill>
-                          <a:latin typeface="Calibri"/>
-                        </a:rPr>
-                        <a:t>parcourir, tester la connexité</a:t>
-                      </a:r>
-                    </a:p>
-                  </a:txBody>
-                  <a:tcPr marL="91440" marR="91440" marT="27432" marB="27432" anchor="ctr">
-                    <a:solidFill>
-                      <a:srgbClr val="F3F5F7"/>
-                    </a:solidFill>
-                  </a:tcPr>
-                </a:tc>
-                <a:tc>
-                  <a:txBody>
-                    <a:bodyPr wrap="square"/>
-                    <a:lstStyle/>
-                    <a:p>
-                      <a:pPr algn="l"/>
-                      <a:r>
-                        <a:rPr sz="1400" b="0">
-                          <a:solidFill>
-                            <a:srgbClr val="0B1F2A"/>
-                          </a:solidFill>
-                          <a:latin typeface="Calibri"/>
-                        </a:rPr>
-                        <a:t>NON : ne garantit pas le plus court chemin, ne gère pas le trafic</a:t>
-                      </a:r>
-                    </a:p>
-                  </a:txBody>
-                  <a:tcPr marL="91440" marR="91440" marT="27432" marB="27432" anchor="ctr">
-                    <a:solidFill>
-                      <a:srgbClr val="F3F5F7"/>
-                    </a:solidFill>
-                  </a:tcPr>
-                </a:tc>
-              </a:tr>
-              <a:tr h="566928">
-                <a:tc>
-                  <a:txBody>
-                    <a:bodyPr wrap="square"/>
-                    <a:lstStyle/>
-                    <a:p>
-                      <a:pPr algn="l"/>
-                      <a:r>
-                        <a:rPr sz="1400" b="0">
-                          <a:solidFill>
-                            <a:srgbClr val="0B1F2A"/>
-                          </a:solidFill>
-                          <a:latin typeface="Calibri"/>
-                        </a:rPr>
-                        <a:t>Dijkstra</a:t>
-                      </a:r>
-                    </a:p>
-                  </a:txBody>
-                  <a:tcPr marL="91440" marR="91440" marT="27432" marB="27432" anchor="ctr">
-                    <a:solidFill>
-                      <a:srgbClr val="FFFFFF"/>
-                    </a:solidFill>
-                  </a:tcPr>
-                </a:tc>
-                <a:tc>
-                  <a:txBody>
-                    <a:bodyPr wrap="square"/>
-                    <a:lstStyle/>
-                    <a:p>
-                      <a:pPr algn="l"/>
-                      <a:r>
-                        <a:rPr sz="1400" b="0">
-                          <a:solidFill>
-                            <a:srgbClr val="0B1F2A"/>
-                          </a:solidFill>
-                          <a:latin typeface="Calibri"/>
-                        </a:rPr>
-                        <a:t>plus courts chemins avec poids</a:t>
-                      </a:r>
-                    </a:p>
-                  </a:txBody>
-                  <a:tcPr marL="91440" marR="91440" marT="27432" marB="27432" anchor="ctr">
-                    <a:solidFill>
-                      <a:srgbClr val="FFFFFF"/>
-                    </a:solidFill>
-                  </a:tcPr>
-                </a:tc>
-                <a:tc>
-                  <a:txBody>
-                    <a:bodyPr wrap="square"/>
-                    <a:lstStyle/>
-                    <a:p>
-                      <a:pPr algn="l"/>
-                      <a:r>
-                        <a:rPr sz="1400" b="0">
-                          <a:solidFill>
-                            <a:srgbClr val="0B1F2A"/>
-                          </a:solidFill>
-                          <a:latin typeface="Calibri"/>
-                        </a:rPr>
-                        <a:t>NON : tous les tunnels valent 1 étape, BFS suffit</a:t>
-                      </a:r>
-                    </a:p>
-                  </a:txBody>
-                  <a:tcPr marL="91440" marR="91440" marT="27432" marB="27432" anchor="ctr">
-                    <a:solidFill>
-                      <a:srgbClr val="FFFFFF"/>
-                    </a:solidFill>
-                  </a:tcPr>
-                </a:tc>
-              </a:tr>
-              <a:tr h="566928">
-                <a:tc>
-                  <a:txBody>
-                    <a:bodyPr wrap="square"/>
-                    <a:lstStyle/>
-                    <a:p>
-                      <a:pPr algn="l"/>
-                      <a:r>
-                        <a:rPr sz="1400" b="0">
-                          <a:solidFill>
-                            <a:srgbClr val="0B1F2A"/>
-                          </a:solidFill>
-                          <a:latin typeface="Calibri"/>
-                        </a:rPr>
-                        <a:t>Floyd-Warshall</a:t>
-                      </a:r>
-                    </a:p>
-                  </a:txBody>
-                  <a:tcPr marL="91440" marR="91440" marT="27432" marB="27432" anchor="ctr">
-                    <a:solidFill>
-                      <a:srgbClr val="F3F5F7"/>
-                    </a:solidFill>
-                  </a:tcPr>
-                </a:tc>
-                <a:tc>
-                  <a:txBody>
-                    <a:bodyPr wrap="square"/>
-                    <a:lstStyle/>
-                    <a:p>
-                      <a:pPr algn="l"/>
-                      <a:r>
-                        <a:rPr sz="1400" b="0">
-                          <a:solidFill>
-                            <a:srgbClr val="0B1F2A"/>
-                          </a:solidFill>
-                          <a:latin typeface="Calibri"/>
-                        </a:rPr>
-                        <a:t>distances entre toutes les paires</a:t>
-                      </a:r>
-                    </a:p>
-                  </a:txBody>
-                  <a:tcPr marL="91440" marR="91440" marT="27432" marB="27432" anchor="ctr">
-                    <a:solidFill>
-                      <a:srgbClr val="F3F5F7"/>
-                    </a:solidFill>
-                  </a:tcPr>
-                </a:tc>
-                <a:tc>
-                  <a:txBody>
-                    <a:bodyPr wrap="square"/>
-                    <a:lstStyle/>
-                    <a:p>
-                      <a:pPr algn="l"/>
-                      <a:r>
-                        <a:rPr sz="1400" b="0">
-                          <a:solidFill>
-                            <a:srgbClr val="0B1F2A"/>
-                          </a:solidFill>
-                          <a:latin typeface="Calibri"/>
-                        </a:rPr>
-                        <a:t>NON : on n'a besoin que des distances depuis Sv et Sd</a:t>
-                      </a:r>
-                    </a:p>
-                  </a:txBody>
-                  <a:tcPr marL="91440" marR="91440" marT="27432" marB="27432" anchor="ctr">
-                    <a:solidFill>
-                      <a:srgbClr val="F3F5F7"/>
-                    </a:solidFill>
-                  </a:tcPr>
-                </a:tc>
-              </a:tr>
-            </a:tbl>
-          </a:graphicData>
-        </a:graphic>
-      </p:graphicFrame>
+      <p:pic>
+        <p:nvPicPr>
+          <p:cNvPr id="7" name="Picture 6" descr="shortest_path_vs_flow.png"/>
+          <p:cNvPicPr>
+            <a:picLocks noChangeAspect="1"/>
+          </p:cNvPicPr>
+          <p:nvPr/>
+        </p:nvPicPr>
+        <p:blipFill>
+          <a:blip r:embed="rId2"/>
+          <a:stretch>
+            <a:fillRect/>
+          </a:stretch>
+        </p:blipFill>
+        <p:spPr>
+          <a:xfrm>
+            <a:off x="457200" y="1467649"/>
+            <a:ext cx="7863840" cy="4425622"/>
+          </a:xfrm>
+          <a:prstGeom prst="rect">
+            <a:avLst/>
+          </a:prstGeom>
+        </p:spPr>
+      </p:pic>
+      <p:sp>
+        <p:nvSpPr>
+          <p:cNvPr id="8" name="Rounded Rectangle 7"/>
+          <p:cNvSpPr/>
+          <p:nvPr/>
+        </p:nvSpPr>
+        <p:spPr>
+          <a:xfrm>
+            <a:off x="8549640" y="1600200"/>
+            <a:ext cx="3154680" cy="1280160"/>
+          </a:xfrm>
+          <a:prstGeom prst="roundRect">
+            <a:avLst>
+              <a:gd name="adj" fmla="val 8000"/>
+            </a:avLst>
+          </a:prstGeom>
+          <a:solidFill>
+            <a:srgbClr val="F3F5F7"/>
+          </a:solidFill>
+          <a:ln>
+            <a:noFill/>
+          </a:ln>
+          <a:effectLst/>
+        </p:spPr>
+        <p:style>
+          <a:lnRef idx="1">
+            <a:schemeClr val="accent1"/>
+          </a:lnRef>
+          <a:fillRef idx="3">
+            <a:schemeClr val="accent1"/>
+          </a:fillRef>
+          <a:effectRef idx="2">
+            <a:schemeClr val="accent1"/>
+          </a:effectRef>
+          <a:fontRef idx="minor">
+            <a:schemeClr val="lt1"/>
+          </a:fontRef>
+        </p:style>
+        <p:txBody>
+          <a:bodyPr rtlCol="0" anchor="ctr" lIns="0" rIns="0"/>
+          <a:lstStyle/>
+          <a:p>
+            <a:pPr algn="ctr"/>
+          </a:p>
+        </p:txBody>
+      </p:sp>
+      <p:sp>
+        <p:nvSpPr>
+          <p:cNvPr id="9" name="TextBox 8"/>
+          <p:cNvSpPr txBox="1"/>
+          <p:nvPr/>
+        </p:nvSpPr>
+        <p:spPr>
+          <a:xfrm>
+            <a:off x="8732520" y="1737360"/>
+            <a:ext cx="2834640" cy="1051560"/>
+          </a:xfrm>
+          <a:prstGeom prst="rect">
+            <a:avLst/>
+          </a:prstGeom>
+          <a:noFill/>
+        </p:spPr>
+        <p:txBody>
+          <a:bodyPr wrap="square" lIns="0" rIns="0" tIns="0" bIns="0" anchor="t">
+            <a:spAutoFit/>
+          </a:bodyPr>
+          <a:lstStyle/>
+          <a:p>
+            <a:pPr algn="l">
+              <a:lnSpc>
+                <a:spcPct val="100000"/>
+              </a:lnSpc>
+            </a:pPr>
+            <a:r>
+              <a:rPr sz="1700" b="1" i="0">
+                <a:solidFill>
+                  <a:srgbClr val="0B1F2A"/>
+                </a:solidFill>
+                <a:latin typeface="Calibri"/>
+              </a:rPr>
+              <a:t>BFS</a:t>
+            </a:r>
+          </a:p>
+          <a:p>
+            <a:pPr algn="l">
+              <a:lnSpc>
+                <a:spcPct val="100000"/>
+              </a:lnSpc>
+            </a:pPr>
+            <a:r>
+              <a:rPr sz="1350" b="0" i="0">
+                <a:solidFill>
+                  <a:srgbClr val="5B636A"/>
+                </a:solidFill>
+                <a:latin typeface="Calibri"/>
+              </a:rPr>
+              <a:t>utile pour trouver la distance minimale (ici d = 2) : on l'utilise.</a:t>
+            </a:r>
+          </a:p>
+        </p:txBody>
+      </p:sp>
+      <p:sp>
+        <p:nvSpPr>
+          <p:cNvPr id="10" name="Rounded Rectangle 9"/>
+          <p:cNvSpPr/>
+          <p:nvPr/>
+        </p:nvSpPr>
+        <p:spPr>
+          <a:xfrm>
+            <a:off x="8549640" y="3063240"/>
+            <a:ext cx="3154680" cy="1280160"/>
+          </a:xfrm>
+          <a:prstGeom prst="roundRect">
+            <a:avLst>
+              <a:gd name="adj" fmla="val 8000"/>
+            </a:avLst>
+          </a:prstGeom>
+          <a:solidFill>
+            <a:srgbClr val="F3F5F7"/>
+          </a:solidFill>
+          <a:ln>
+            <a:noFill/>
+          </a:ln>
+          <a:effectLst/>
+        </p:spPr>
+        <p:style>
+          <a:lnRef idx="1">
+            <a:schemeClr val="accent1"/>
+          </a:lnRef>
+          <a:fillRef idx="3">
+            <a:schemeClr val="accent1"/>
+          </a:fillRef>
+          <a:effectRef idx="2">
+            <a:schemeClr val="accent1"/>
+          </a:effectRef>
+          <a:fontRef idx="minor">
+            <a:schemeClr val="lt1"/>
+          </a:fontRef>
+        </p:style>
+        <p:txBody>
+          <a:bodyPr rtlCol="0" anchor="ctr" lIns="0" rIns="0"/>
+          <a:lstStyle/>
+          <a:p>
+            <a:pPr algn="ctr"/>
+          </a:p>
+        </p:txBody>
+      </p:sp>
+      <p:sp>
+        <p:nvSpPr>
+          <p:cNvPr id="11" name="TextBox 10"/>
+          <p:cNvSpPr txBox="1"/>
+          <p:nvPr/>
+        </p:nvSpPr>
+        <p:spPr>
+          <a:xfrm>
+            <a:off x="8732520" y="3200400"/>
+            <a:ext cx="2834640" cy="1051560"/>
+          </a:xfrm>
+          <a:prstGeom prst="rect">
+            <a:avLst/>
+          </a:prstGeom>
+          <a:noFill/>
+        </p:spPr>
+        <p:txBody>
+          <a:bodyPr wrap="square" lIns="0" rIns="0" tIns="0" bIns="0" anchor="t">
+            <a:spAutoFit/>
+          </a:bodyPr>
+          <a:lstStyle/>
+          <a:p>
+            <a:pPr algn="l">
+              <a:lnSpc>
+                <a:spcPct val="100000"/>
+              </a:lnSpc>
+            </a:pPr>
+            <a:r>
+              <a:rPr sz="1700" b="1" i="0">
+                <a:solidFill>
+                  <a:srgbClr val="0B1F2A"/>
+                </a:solidFill>
+                <a:latin typeface="Calibri"/>
+              </a:rPr>
+              <a:t>Dijkstra</a:t>
+            </a:r>
+          </a:p>
+          <a:p>
+            <a:pPr algn="l">
+              <a:lnSpc>
+                <a:spcPct val="100000"/>
+              </a:lnSpc>
+            </a:pPr>
+            <a:r>
+              <a:rPr sz="1350" b="0" i="0">
+                <a:solidFill>
+                  <a:srgbClr val="5B636A"/>
+                </a:solidFill>
+                <a:latin typeface="Calibri"/>
+              </a:rPr>
+              <a:t>inutile ici car tous les tunnels coûtent 1 : même résultat que BFS.</a:t>
+            </a:r>
+          </a:p>
+        </p:txBody>
+      </p:sp>
+      <p:sp>
+        <p:nvSpPr>
+          <p:cNvPr id="12" name="Rounded Rectangle 11"/>
+          <p:cNvSpPr/>
+          <p:nvPr/>
+        </p:nvSpPr>
+        <p:spPr>
+          <a:xfrm>
+            <a:off x="8549640" y="4526280"/>
+            <a:ext cx="3154680" cy="1280160"/>
+          </a:xfrm>
+          <a:prstGeom prst="roundRect">
+            <a:avLst>
+              <a:gd name="adj" fmla="val 8000"/>
+            </a:avLst>
+          </a:prstGeom>
+          <a:solidFill>
+            <a:srgbClr val="FDE9E0"/>
+          </a:solidFill>
+          <a:ln>
+            <a:noFill/>
+          </a:ln>
+          <a:effectLst/>
+        </p:spPr>
+        <p:style>
+          <a:lnRef idx="1">
+            <a:schemeClr val="accent1"/>
+          </a:lnRef>
+          <a:fillRef idx="3">
+            <a:schemeClr val="accent1"/>
+          </a:fillRef>
+          <a:effectRef idx="2">
+            <a:schemeClr val="accent1"/>
+          </a:effectRef>
+          <a:fontRef idx="minor">
+            <a:schemeClr val="lt1"/>
+          </a:fontRef>
+        </p:style>
+        <p:txBody>
+          <a:bodyPr rtlCol="0" anchor="ctr" lIns="0" rIns="0"/>
+          <a:lstStyle/>
+          <a:p>
+            <a:pPr algn="ctr"/>
+          </a:p>
+        </p:txBody>
+      </p:sp>
+      <p:sp>
+        <p:nvSpPr>
+          <p:cNvPr id="13" name="TextBox 12"/>
+          <p:cNvSpPr txBox="1"/>
+          <p:nvPr/>
+        </p:nvSpPr>
+        <p:spPr>
+          <a:xfrm>
+            <a:off x="8732520" y="4663440"/>
+            <a:ext cx="2834640" cy="1051560"/>
+          </a:xfrm>
+          <a:prstGeom prst="rect">
+            <a:avLst/>
+          </a:prstGeom>
+          <a:noFill/>
+        </p:spPr>
+        <p:txBody>
+          <a:bodyPr wrap="square" lIns="0" rIns="0" tIns="0" bIns="0" anchor="t">
+            <a:spAutoFit/>
+          </a:bodyPr>
+          <a:lstStyle/>
+          <a:p>
+            <a:pPr algn="l">
+              <a:lnSpc>
+                <a:spcPct val="100000"/>
+              </a:lnSpc>
+            </a:pPr>
+            <a:r>
+              <a:rPr sz="1700" b="1" i="0">
+                <a:solidFill>
+                  <a:srgbClr val="EB6834"/>
+                </a:solidFill>
+                <a:latin typeface="Calibri"/>
+              </a:rPr>
+              <a:t>Max-flow temporel</a:t>
+            </a:r>
+          </a:p>
+          <a:p>
+            <a:pPr algn="l">
+              <a:lnSpc>
+                <a:spcPct val="100000"/>
+              </a:lnSpc>
+            </a:pPr>
+            <a:r>
+              <a:rPr sz="1350" b="0" i="0">
+                <a:solidFill>
+                  <a:srgbClr val="5B636A"/>
+                </a:solidFill>
+                <a:latin typeface="Calibri"/>
+              </a:rPr>
+              <a:t>répartit plusieurs fourmis sur plusieurs chemins en respectant les capacités.</a:t>
+            </a:r>
+          </a:p>
+        </p:txBody>
+      </p:sp>
+      <p:sp>
+        <p:nvSpPr>
+          <p:cNvPr id="14" name="TextBox 13"/>
+          <p:cNvSpPr txBox="1"/>
+          <p:nvPr/>
+        </p:nvSpPr>
+        <p:spPr>
+          <a:xfrm>
+            <a:off x="548640" y="5989320"/>
+            <a:ext cx="11155680" cy="365760"/>
+          </a:xfrm>
+          <a:prstGeom prst="rect">
+            <a:avLst/>
+          </a:prstGeom>
+          <a:noFill/>
+        </p:spPr>
+        <p:txBody>
+          <a:bodyPr wrap="square" lIns="0" rIns="0" tIns="0" bIns="0" anchor="t">
+            <a:spAutoFit/>
+          </a:bodyPr>
+          <a:lstStyle/>
+          <a:p>
+            <a:pPr algn="l">
+              <a:lnSpc>
+                <a:spcPct val="100000"/>
+              </a:lnSpc>
+            </a:pPr>
+            <a:r>
+              <a:rPr sz="1400" b="1" i="0">
+                <a:solidFill>
+                  <a:srgbClr val="0B1F2A"/>
+                </a:solidFill>
+                <a:latin typeface="Calibri"/>
+              </a:rPr>
+              <a:t>Plus court chemin individuel ≠ temps minimum pour toute la colonie : d'où le graphe temporel et le max-flow.</a:t>
+            </a:r>
+          </a:p>
+        </p:txBody>
+      </p:sp>
     </p:spTree>
   </p:cSld>
   <p:clrMapOvr>
@@ -16650,7 +17105,7 @@
                 </a:solidFill>
                 <a:latin typeface="Calibri"/>
               </a:rPr>
-              <a:t>Graphe temporel et découpage des salles</a:t>
+              <a:t>Chaque algorithme répond à un problème différent</a:t>
             </a:r>
           </a:p>
         </p:txBody>
@@ -16689,7 +17144,7 @@
                 </a:solidFill>
                 <a:latin typeface="Calibri"/>
               </a:rPr>
-              <a:t>Transformer « position + temps » en un problème de flot statique</a:t>
+              <a:t>Aucun n'est « mauvais » : on utilise celui qui correspond à la question posée</a:t>
             </a:r>
           </a:p>
         </p:txBody>
@@ -16772,399 +17227,530 @@
           </a:p>
         </p:txBody>
       </p:sp>
-      <p:pic>
-        <p:nvPicPr>
-          <p:cNvPr id="7" name="Picture 6" descr="time_expanded.png"/>
-          <p:cNvPicPr>
-            <a:picLocks noChangeAspect="1"/>
-          </p:cNvPicPr>
-          <p:nvPr/>
-        </p:nvPicPr>
-        <p:blipFill>
-          <a:blip r:embed="rId2"/>
-          <a:stretch>
-            <a:fillRect/>
-          </a:stretch>
-        </p:blipFill>
-        <p:spPr>
-          <a:xfrm>
-            <a:off x="457200" y="1617379"/>
-            <a:ext cx="6309360" cy="3623242"/>
-          </a:xfrm>
-          <a:prstGeom prst="rect">
-            <a:avLst/>
-          </a:prstGeom>
-        </p:spPr>
-      </p:pic>
-      <p:sp>
-        <p:nvSpPr>
-          <p:cNvPr id="8" name="TextBox 7"/>
-          <p:cNvSpPr txBox="1"/>
-          <p:nvPr/>
-        </p:nvSpPr>
-        <p:spPr>
-          <a:xfrm>
-            <a:off x="7040880" y="1645920"/>
-            <a:ext cx="4663440" cy="731520"/>
-          </a:xfrm>
-          <a:prstGeom prst="rect">
-            <a:avLst/>
-          </a:prstGeom>
-          <a:noFill/>
-        </p:spPr>
-        <p:txBody>
-          <a:bodyPr wrap="square" lIns="0" rIns="0" tIns="0" bIns="0" anchor="t">
-            <a:spAutoFit/>
-          </a:bodyPr>
-          <a:lstStyle/>
-          <a:p>
-            <a:pPr algn="l">
-              <a:lnSpc>
-                <a:spcPct val="100000"/>
-              </a:lnSpc>
-            </a:pPr>
-            <a:r>
-              <a:rPr sz="1600" b="1" i="0">
-                <a:solidFill>
-                  <a:srgbClr val="0B1F2A"/>
-                </a:solidFill>
-                <a:latin typeface="Calibri"/>
-              </a:rPr>
-              <a:t>Sommets</a:t>
-            </a:r>
-          </a:p>
-          <a:p>
-            <a:pPr algn="l">
-              <a:lnSpc>
-                <a:spcPct val="100000"/>
-              </a:lnSpc>
-            </a:pPr>
-            <a:r>
-              <a:rPr sz="1350" b="0" i="0">
-                <a:solidFill>
-                  <a:srgbClr val="5B636A"/>
-                </a:solidFill>
-                <a:latin typeface="Calibri"/>
-              </a:rPr>
-              <a:t>(salle, t) pour chaque salle et chaque instant 0 … T</a:t>
-            </a:r>
-          </a:p>
-        </p:txBody>
-      </p:sp>
-      <p:sp>
-        <p:nvSpPr>
-          <p:cNvPr id="9" name="TextBox 8"/>
-          <p:cNvSpPr txBox="1"/>
-          <p:nvPr/>
-        </p:nvSpPr>
-        <p:spPr>
-          <a:xfrm>
-            <a:off x="7040880" y="2395728"/>
-            <a:ext cx="4663440" cy="731520"/>
-          </a:xfrm>
-          <a:prstGeom prst="rect">
-            <a:avLst/>
-          </a:prstGeom>
-          <a:noFill/>
-        </p:spPr>
-        <p:txBody>
-          <a:bodyPr wrap="square" lIns="0" rIns="0" tIns="0" bIns="0" anchor="t">
-            <a:spAutoFit/>
-          </a:bodyPr>
-          <a:lstStyle/>
-          <a:p>
-            <a:pPr algn="l">
-              <a:lnSpc>
-                <a:spcPct val="100000"/>
-              </a:lnSpc>
-            </a:pPr>
-            <a:r>
-              <a:rPr sz="1600" b="1" i="0">
-                <a:solidFill>
-                  <a:srgbClr val="0B1F2A"/>
-                </a:solidFill>
-                <a:latin typeface="Calibri"/>
-              </a:rPr>
-              <a:t>Attendre</a:t>
-            </a:r>
-          </a:p>
-          <a:p>
-            <a:pPr algn="l">
-              <a:lnSpc>
-                <a:spcPct val="100000"/>
-              </a:lnSpc>
-            </a:pPr>
-            <a:r>
-              <a:rPr sz="1350" b="0" i="0">
-                <a:solidFill>
-                  <a:srgbClr val="5B636A"/>
-                </a:solidFill>
-                <a:latin typeface="Calibri"/>
-              </a:rPr>
-              <a:t>(salle, t) → (salle, t+1)</a:t>
-            </a:r>
-          </a:p>
-        </p:txBody>
-      </p:sp>
-      <p:sp>
-        <p:nvSpPr>
-          <p:cNvPr id="10" name="TextBox 9"/>
-          <p:cNvSpPr txBox="1"/>
-          <p:nvPr/>
-        </p:nvSpPr>
-        <p:spPr>
-          <a:xfrm>
-            <a:off x="7040880" y="3145536"/>
-            <a:ext cx="4663440" cy="731520"/>
-          </a:xfrm>
-          <a:prstGeom prst="rect">
-            <a:avLst/>
-          </a:prstGeom>
-          <a:noFill/>
-        </p:spPr>
-        <p:txBody>
-          <a:bodyPr wrap="square" lIns="0" rIns="0" tIns="0" bIns="0" anchor="t">
-            <a:spAutoFit/>
-          </a:bodyPr>
-          <a:lstStyle/>
-          <a:p>
-            <a:pPr algn="l">
-              <a:lnSpc>
-                <a:spcPct val="100000"/>
-              </a:lnSpc>
-            </a:pPr>
-            <a:r>
-              <a:rPr sz="1600" b="1" i="0">
-                <a:solidFill>
-                  <a:srgbClr val="0B1F2A"/>
-                </a:solidFill>
-                <a:latin typeface="Calibri"/>
-              </a:rPr>
-              <a:t>Se déplacer</a:t>
-            </a:r>
-          </a:p>
-          <a:p>
-            <a:pPr algn="l">
-              <a:lnSpc>
-                <a:spcPct val="100000"/>
-              </a:lnSpc>
-            </a:pPr>
-            <a:r>
-              <a:rPr sz="1350" b="0" i="0">
-                <a:solidFill>
-                  <a:srgbClr val="5B636A"/>
-                </a:solidFill>
-                <a:latin typeface="Calibri"/>
-              </a:rPr>
-              <a:t>(a, t) → (b, t+1) si le tunnel a–b existe ; capacité illimitée</a:t>
-            </a:r>
-          </a:p>
-        </p:txBody>
-      </p:sp>
-      <p:sp>
-        <p:nvSpPr>
-          <p:cNvPr id="11" name="TextBox 10"/>
-          <p:cNvSpPr txBox="1"/>
-          <p:nvPr/>
-        </p:nvSpPr>
-        <p:spPr>
-          <a:xfrm>
-            <a:off x="7040880" y="3895344"/>
-            <a:ext cx="4663440" cy="731520"/>
-          </a:xfrm>
-          <a:prstGeom prst="rect">
-            <a:avLst/>
-          </a:prstGeom>
-          <a:noFill/>
-        </p:spPr>
-        <p:txBody>
-          <a:bodyPr wrap="square" lIns="0" rIns="0" tIns="0" bIns="0" anchor="t">
-            <a:spAutoFit/>
-          </a:bodyPr>
-          <a:lstStyle/>
-          <a:p>
-            <a:pPr algn="l">
-              <a:lnSpc>
-                <a:spcPct val="100000"/>
-              </a:lnSpc>
-            </a:pPr>
-            <a:r>
-              <a:rPr sz="1600" b="1" i="0">
-                <a:solidFill>
-                  <a:srgbClr val="0B1F2A"/>
-                </a:solidFill>
-                <a:latin typeface="Calibri"/>
-              </a:rPr>
-              <a:t>Capacité SN{X}</a:t>
-            </a:r>
-          </a:p>
-          <a:p>
-            <a:pPr algn="l">
-              <a:lnSpc>
-                <a:spcPct val="100000"/>
-              </a:lnSpc>
-            </a:pPr>
-            <a:r>
-              <a:rPr sz="1350" b="0" i="0">
-                <a:solidFill>
-                  <a:srgbClr val="5B636A"/>
-                </a:solidFill>
-                <a:latin typeface="Calibri"/>
-              </a:rPr>
-              <a:t>chaque (salle, t) est coupé en entrée → sortie de capacité X : c'est le node splitting</a:t>
-            </a:r>
-          </a:p>
-        </p:txBody>
-      </p:sp>
-      <p:sp>
-        <p:nvSpPr>
-          <p:cNvPr id="12" name="TextBox 11"/>
-          <p:cNvSpPr txBox="1"/>
-          <p:nvPr/>
-        </p:nvSpPr>
-        <p:spPr>
-          <a:xfrm>
-            <a:off x="7040880" y="4645152"/>
-            <a:ext cx="4663440" cy="731520"/>
-          </a:xfrm>
-          <a:prstGeom prst="rect">
-            <a:avLst/>
-          </a:prstGeom>
-          <a:noFill/>
-        </p:spPr>
-        <p:txBody>
-          <a:bodyPr wrap="square" lIns="0" rIns="0" tIns="0" bIns="0" anchor="t">
-            <a:spAutoFit/>
-          </a:bodyPr>
-          <a:lstStyle/>
-          <a:p>
-            <a:pPr algn="l">
-              <a:lnSpc>
-                <a:spcPct val="100000"/>
-              </a:lnSpc>
-            </a:pPr>
-            <a:r>
-              <a:rPr sz="1600" b="1" i="0">
-                <a:solidFill>
-                  <a:srgbClr val="0B1F2A"/>
-                </a:solidFill>
-                <a:latin typeface="Calibri"/>
-              </a:rPr>
-              <a:t>Sv et Sd</a:t>
-            </a:r>
-          </a:p>
-          <a:p>
-            <a:pPr algn="l">
-              <a:lnSpc>
-                <a:spcPct val="100000"/>
-              </a:lnSpc>
-            </a:pPr>
-            <a:r>
-              <a:rPr sz="1350" b="0" i="0">
-                <a:solidFill>
-                  <a:srgbClr val="5B636A"/>
-                </a:solidFill>
-                <a:latin typeface="Calibri"/>
-              </a:rPr>
-              <a:t>capacité F : jamais limitants ; Sd absorbant (on n'en ressort pas)</a:t>
-            </a:r>
-          </a:p>
-        </p:txBody>
-      </p:sp>
-      <p:sp>
-        <p:nvSpPr>
-          <p:cNvPr id="13" name="TextBox 12"/>
-          <p:cNvSpPr txBox="1"/>
-          <p:nvPr/>
-        </p:nvSpPr>
-        <p:spPr>
-          <a:xfrm>
-            <a:off x="7040880" y="5394960"/>
-            <a:ext cx="4663440" cy="731520"/>
-          </a:xfrm>
-          <a:prstGeom prst="rect">
-            <a:avLst/>
-          </a:prstGeom>
-          <a:noFill/>
-        </p:spPr>
-        <p:txBody>
-          <a:bodyPr wrap="square" lIns="0" rIns="0" tIns="0" bIns="0" anchor="t">
-            <a:spAutoFit/>
-          </a:bodyPr>
-          <a:lstStyle/>
-          <a:p>
-            <a:pPr algn="l">
-              <a:lnSpc>
-                <a:spcPct val="100000"/>
-              </a:lnSpc>
-            </a:pPr>
-            <a:r>
-              <a:rPr sz="1600" b="1" i="0">
-                <a:solidFill>
-                  <a:srgbClr val="0B1F2A"/>
-                </a:solidFill>
-                <a:latin typeface="Calibri"/>
-              </a:rPr>
-              <a:t>Une unité de flot</a:t>
-            </a:r>
-          </a:p>
-          <a:p>
-            <a:pPr algn="l">
-              <a:lnSpc>
-                <a:spcPct val="100000"/>
-              </a:lnSpc>
-            </a:pPr>
-            <a:r>
-              <a:rPr sz="1350" b="0" i="0">
-                <a:solidFill>
-                  <a:srgbClr val="5B636A"/>
-                </a:solidFill>
-                <a:latin typeface="Calibri"/>
-              </a:rPr>
-              <a:t>= une fourmi ; flot de valeur F = toutes les fourmis arrivent en T étapes</a:t>
-            </a:r>
-          </a:p>
-        </p:txBody>
-      </p:sp>
-      <p:sp>
-        <p:nvSpPr>
-          <p:cNvPr id="14" name="TextBox 13"/>
-          <p:cNvSpPr txBox="1"/>
-          <p:nvPr/>
-        </p:nvSpPr>
-        <p:spPr>
-          <a:xfrm>
-            <a:off x="548640" y="5669280"/>
-            <a:ext cx="6217920" cy="548640"/>
-          </a:xfrm>
-          <a:prstGeom prst="rect">
-            <a:avLst/>
-          </a:prstGeom>
-          <a:noFill/>
-        </p:spPr>
-        <p:txBody>
-          <a:bodyPr wrap="square" lIns="0" rIns="0" tIns="0" bIns="0" anchor="t">
-            <a:spAutoFit/>
-          </a:bodyPr>
-          <a:lstStyle/>
-          <a:p>
-            <a:pPr algn="l">
-              <a:lnSpc>
-                <a:spcPct val="100000"/>
-              </a:lnSpc>
-            </a:pPr>
-            <a:r>
-              <a:rPr sz="1300" b="0" i="0">
-                <a:solidFill>
-                  <a:srgbClr val="0B1F2A"/>
-                </a:solidFill>
-                <a:latin typeface="Calibri"/>
-              </a:rPr>
-              <a:t>Premier T faisable = optimum : si T marche, T+1 marche aussi (on attend dans Sd), et on teste T = d, d+1, … dans l'ordre.</a:t>
-            </a:r>
-          </a:p>
-        </p:txBody>
-      </p:sp>
+      <p:graphicFrame>
+        <p:nvGraphicFramePr>
+          <p:cNvPr id="7" name="Table 6"/>
+          <p:cNvGraphicFramePr>
+            <a:graphicFrameLocks noGrp="1"/>
+          </p:cNvGraphicFramePr>
+          <p:nvPr/>
+        </p:nvGraphicFramePr>
+        <p:xfrm>
+          <a:off x="548640" y="1600200"/>
+          <a:ext cx="11064240" cy="3968496"/>
+        </p:xfrm>
+        <a:graphic>
+          <a:graphicData uri="http://schemas.openxmlformats.org/drawingml/2006/table">
+            <a:tbl>
+              <a:tblPr firstRow="1" bandRow="1">
+                <a:tableStyleId>{5C22544A-7EE6-4342-B048-85BDC9FD1C3A}</a:tableStyleId>
+              </a:tblPr>
+              <a:tblGrid>
+                <a:gridCol w="2377440"/>
+                <a:gridCol w="4572000"/>
+                <a:gridCol w="4114800"/>
+              </a:tblGrid>
+              <a:tr h="566928">
+                <a:tc>
+                  <a:txBody>
+                    <a:bodyPr wrap="square"/>
+                    <a:lstStyle/>
+                    <a:p>
+                      <a:pPr algn="l"/>
+                      <a:r>
+                        <a:rPr sz="1600" b="1">
+                          <a:solidFill>
+                            <a:srgbClr val="FFFFFF"/>
+                          </a:solidFill>
+                          <a:latin typeface="Calibri"/>
+                        </a:rPr>
+                        <a:t>Algorithme</a:t>
+                      </a:r>
+                    </a:p>
+                  </a:txBody>
+                  <a:tcPr marL="91440" marR="91440" marT="27432" marB="27432" anchor="ctr">
+                    <a:solidFill>
+                      <a:srgbClr val="0B1F2A"/>
+                    </a:solidFill>
+                  </a:tcPr>
+                </a:tc>
+                <a:tc>
+                  <a:txBody>
+                    <a:bodyPr wrap="square"/>
+                    <a:lstStyle/>
+                    <a:p>
+                      <a:pPr algn="l"/>
+                      <a:r>
+                        <a:rPr sz="1600" b="1">
+                          <a:solidFill>
+                            <a:srgbClr val="FFFFFF"/>
+                          </a:solidFill>
+                          <a:latin typeface="Calibri"/>
+                        </a:rPr>
+                        <a:t>Sert à quoi ici ?</a:t>
+                      </a:r>
+                    </a:p>
+                  </a:txBody>
+                  <a:tcPr marL="91440" marR="91440" marT="27432" marB="27432" anchor="ctr">
+                    <a:solidFill>
+                      <a:srgbClr val="0B1F2A"/>
+                    </a:solidFill>
+                  </a:tcPr>
+                </a:tc>
+                <a:tc>
+                  <a:txBody>
+                    <a:bodyPr wrap="square"/>
+                    <a:lstStyle/>
+                    <a:p>
+                      <a:pPr algn="l"/>
+                      <a:r>
+                        <a:rPr sz="1600" b="1">
+                          <a:solidFill>
+                            <a:srgbClr val="FFFFFF"/>
+                          </a:solidFill>
+                          <a:latin typeface="Calibri"/>
+                        </a:rPr>
+                        <a:t>Utilisé ?</a:t>
+                      </a:r>
+                    </a:p>
+                  </a:txBody>
+                  <a:tcPr marL="91440" marR="91440" marT="27432" marB="27432" anchor="ctr">
+                    <a:solidFill>
+                      <a:srgbClr val="0B1F2A"/>
+                    </a:solidFill>
+                  </a:tcPr>
+                </a:tc>
+              </a:tr>
+              <a:tr h="566928">
+                <a:tc>
+                  <a:txBody>
+                    <a:bodyPr wrap="square"/>
+                    <a:lstStyle/>
+                    <a:p>
+                      <a:pPr algn="l"/>
+                      <a:r>
+                        <a:rPr sz="1600" b="0">
+                          <a:solidFill>
+                            <a:srgbClr val="0B1F2A"/>
+                          </a:solidFill>
+                          <a:latin typeface="Calibri"/>
+                        </a:rPr>
+                        <a:t>BFS</a:t>
+                      </a:r>
+                    </a:p>
+                  </a:txBody>
+                  <a:tcPr marL="91440" marR="91440" marT="27432" marB="27432" anchor="ctr">
+                    <a:solidFill>
+                      <a:srgbClr val="FDE9E0"/>
+                    </a:solidFill>
+                  </a:tcPr>
+                </a:tc>
+                <a:tc>
+                  <a:txBody>
+                    <a:bodyPr wrap="square"/>
+                    <a:lstStyle/>
+                    <a:p>
+                      <a:pPr algn="l"/>
+                      <a:r>
+                        <a:rPr sz="1600" b="0">
+                          <a:solidFill>
+                            <a:srgbClr val="0B1F2A"/>
+                          </a:solidFill>
+                          <a:latin typeface="Calibri"/>
+                        </a:rPr>
+                        <a:t>distance minimale / chemins non pondérés</a:t>
+                      </a:r>
+                    </a:p>
+                  </a:txBody>
+                  <a:tcPr marL="91440" marR="91440" marT="27432" marB="27432" anchor="ctr">
+                    <a:solidFill>
+                      <a:srgbClr val="FDE9E0"/>
+                    </a:solidFill>
+                  </a:tcPr>
+                </a:tc>
+                <a:tc>
+                  <a:txBody>
+                    <a:bodyPr wrap="square"/>
+                    <a:lstStyle/>
+                    <a:p>
+                      <a:pPr algn="l"/>
+                      <a:r>
+                        <a:rPr sz="1600" b="1">
+                          <a:solidFill>
+                            <a:srgbClr val="0B1F2A"/>
+                          </a:solidFill>
+                          <a:latin typeface="Calibri"/>
+                        </a:rPr>
+                        <a:t>OUI : borne basse d (ants.bfs_distances)</a:t>
+                      </a:r>
+                    </a:p>
+                  </a:txBody>
+                  <a:tcPr marL="91440" marR="91440" marT="27432" marB="27432" anchor="ctr">
+                    <a:solidFill>
+                      <a:srgbClr val="FDE9E0"/>
+                    </a:solidFill>
+                  </a:tcPr>
+                </a:tc>
+              </a:tr>
+              <a:tr h="566928">
+                <a:tc>
+                  <a:txBody>
+                    <a:bodyPr wrap="square"/>
+                    <a:lstStyle/>
+                    <a:p>
+                      <a:pPr algn="l"/>
+                      <a:r>
+                        <a:rPr sz="1600" b="0">
+                          <a:solidFill>
+                            <a:srgbClr val="0B1F2A"/>
+                          </a:solidFill>
+                          <a:latin typeface="Calibri"/>
+                        </a:rPr>
+                        <a:t>DFS</a:t>
+                      </a:r>
+                    </a:p>
+                  </a:txBody>
+                  <a:tcPr marL="91440" marR="91440" marT="27432" marB="27432" anchor="ctr">
+                    <a:solidFill>
+                      <a:srgbClr val="F3F5F7"/>
+                    </a:solidFill>
+                  </a:tcPr>
+                </a:tc>
+                <a:tc>
+                  <a:txBody>
+                    <a:bodyPr wrap="square"/>
+                    <a:lstStyle/>
+                    <a:p>
+                      <a:pPr algn="l"/>
+                      <a:r>
+                        <a:rPr sz="1600" b="0">
+                          <a:solidFill>
+                            <a:srgbClr val="0B1F2A"/>
+                          </a:solidFill>
+                          <a:latin typeface="Calibri"/>
+                        </a:rPr>
+                        <a:t>exploration, mais pas de minimum garanti</a:t>
+                      </a:r>
+                    </a:p>
+                  </a:txBody>
+                  <a:tcPr marL="91440" marR="91440" marT="27432" marB="27432" anchor="ctr">
+                    <a:solidFill>
+                      <a:srgbClr val="F3F5F7"/>
+                    </a:solidFill>
+                  </a:tcPr>
+                </a:tc>
+                <a:tc>
+                  <a:txBody>
+                    <a:bodyPr wrap="square"/>
+                    <a:lstStyle/>
+                    <a:p>
+                      <a:pPr algn="l"/>
+                      <a:r>
+                        <a:rPr sz="1600" b="0">
+                          <a:solidFill>
+                            <a:srgbClr val="0B1F2A"/>
+                          </a:solidFill>
+                          <a:latin typeface="Calibri"/>
+                        </a:rPr>
+                        <a:t>NON</a:t>
+                      </a:r>
+                    </a:p>
+                  </a:txBody>
+                  <a:tcPr marL="91440" marR="91440" marT="27432" marB="27432" anchor="ctr">
+                    <a:solidFill>
+                      <a:srgbClr val="F3F5F7"/>
+                    </a:solidFill>
+                  </a:tcPr>
+                </a:tc>
+              </a:tr>
+              <a:tr h="566928">
+                <a:tc>
+                  <a:txBody>
+                    <a:bodyPr wrap="square"/>
+                    <a:lstStyle/>
+                    <a:p>
+                      <a:pPr algn="l"/>
+                      <a:r>
+                        <a:rPr sz="1600" b="0">
+                          <a:solidFill>
+                            <a:srgbClr val="0B1F2A"/>
+                          </a:solidFill>
+                          <a:latin typeface="Calibri"/>
+                        </a:rPr>
+                        <a:t>Dijkstra</a:t>
+                      </a:r>
+                    </a:p>
+                  </a:txBody>
+                  <a:tcPr marL="91440" marR="91440" marT="27432" marB="27432" anchor="ctr">
+                    <a:solidFill>
+                      <a:srgbClr val="FFFFFF"/>
+                    </a:solidFill>
+                  </a:tcPr>
+                </a:tc>
+                <a:tc>
+                  <a:txBody>
+                    <a:bodyPr wrap="square"/>
+                    <a:lstStyle/>
+                    <a:p>
+                      <a:pPr algn="l"/>
+                      <a:r>
+                        <a:rPr sz="1600" b="0">
+                          <a:solidFill>
+                            <a:srgbClr val="0B1F2A"/>
+                          </a:solidFill>
+                          <a:latin typeface="Calibri"/>
+                        </a:rPr>
+                        <a:t>plus court chemin pondéré</a:t>
+                      </a:r>
+                    </a:p>
+                  </a:txBody>
+                  <a:tcPr marL="91440" marR="91440" marT="27432" marB="27432" anchor="ctr">
+                    <a:solidFill>
+                      <a:srgbClr val="FFFFFF"/>
+                    </a:solidFill>
+                  </a:tcPr>
+                </a:tc>
+                <a:tc>
+                  <a:txBody>
+                    <a:bodyPr wrap="square"/>
+                    <a:lstStyle/>
+                    <a:p>
+                      <a:pPr algn="l"/>
+                      <a:r>
+                        <a:rPr sz="1600" b="0">
+                          <a:solidFill>
+                            <a:srgbClr val="0B1F2A"/>
+                          </a:solidFill>
+                          <a:latin typeface="Calibri"/>
+                        </a:rPr>
+                        <a:t>NON, inutile ici (tous les tunnels valent 1)</a:t>
+                      </a:r>
+                    </a:p>
+                  </a:txBody>
+                  <a:tcPr marL="91440" marR="91440" marT="27432" marB="27432" anchor="ctr">
+                    <a:solidFill>
+                      <a:srgbClr val="FFFFFF"/>
+                    </a:solidFill>
+                  </a:tcPr>
+                </a:tc>
+              </a:tr>
+              <a:tr h="566928">
+                <a:tc>
+                  <a:txBody>
+                    <a:bodyPr wrap="square"/>
+                    <a:lstStyle/>
+                    <a:p>
+                      <a:pPr algn="l"/>
+                      <a:r>
+                        <a:rPr sz="1600" b="0">
+                          <a:solidFill>
+                            <a:srgbClr val="0B1F2A"/>
+                          </a:solidFill>
+                          <a:latin typeface="Calibri"/>
+                        </a:rPr>
+                        <a:t>Floyd-Warshall</a:t>
+                      </a:r>
+                    </a:p>
+                  </a:txBody>
+                  <a:tcPr marL="91440" marR="91440" marT="27432" marB="27432" anchor="ctr">
+                    <a:solidFill>
+                      <a:srgbClr val="F3F5F7"/>
+                    </a:solidFill>
+                  </a:tcPr>
+                </a:tc>
+                <a:tc>
+                  <a:txBody>
+                    <a:bodyPr wrap="square"/>
+                    <a:lstStyle/>
+                    <a:p>
+                      <a:pPr algn="l"/>
+                      <a:r>
+                        <a:rPr sz="1600" b="0">
+                          <a:solidFill>
+                            <a:srgbClr val="0B1F2A"/>
+                          </a:solidFill>
+                          <a:latin typeface="Calibri"/>
+                        </a:rPr>
+                        <a:t>toutes les distances entre toutes les paires</a:t>
+                      </a:r>
+                    </a:p>
+                  </a:txBody>
+                  <a:tcPr marL="91440" marR="91440" marT="27432" marB="27432" anchor="ctr">
+                    <a:solidFill>
+                      <a:srgbClr val="F3F5F7"/>
+                    </a:solidFill>
+                  </a:tcPr>
+                </a:tc>
+                <a:tc>
+                  <a:txBody>
+                    <a:bodyPr wrap="square"/>
+                    <a:lstStyle/>
+                    <a:p>
+                      <a:pPr algn="l"/>
+                      <a:r>
+                        <a:rPr sz="1600" b="0">
+                          <a:solidFill>
+                            <a:srgbClr val="0B1F2A"/>
+                          </a:solidFill>
+                          <a:latin typeface="Calibri"/>
+                        </a:rPr>
+                        <a:t>NON</a:t>
+                      </a:r>
+                    </a:p>
+                  </a:txBody>
+                  <a:tcPr marL="91440" marR="91440" marT="27432" marB="27432" anchor="ctr">
+                    <a:solidFill>
+                      <a:srgbClr val="F3F5F7"/>
+                    </a:solidFill>
+                  </a:tcPr>
+                </a:tc>
+              </a:tr>
+              <a:tr h="566928">
+                <a:tc>
+                  <a:txBody>
+                    <a:bodyPr wrap="square"/>
+                    <a:lstStyle/>
+                    <a:p>
+                      <a:pPr algn="l"/>
+                      <a:r>
+                        <a:rPr sz="1600" b="0">
+                          <a:solidFill>
+                            <a:srgbClr val="0B1F2A"/>
+                          </a:solidFill>
+                          <a:latin typeface="Calibri"/>
+                        </a:rPr>
+                        <a:t>Edmonds-Karp</a:t>
+                      </a:r>
+                    </a:p>
+                  </a:txBody>
+                  <a:tcPr marL="91440" marR="91440" marT="27432" marB="27432" anchor="ctr">
+                    <a:solidFill>
+                      <a:srgbClr val="FDE9E0"/>
+                    </a:solidFill>
+                  </a:tcPr>
+                </a:tc>
+                <a:tc>
+                  <a:txBody>
+                    <a:bodyPr wrap="square"/>
+                    <a:lstStyle/>
+                    <a:p>
+                      <a:pPr algn="l"/>
+                      <a:r>
+                        <a:rPr sz="1600" b="0">
+                          <a:solidFill>
+                            <a:srgbClr val="0B1F2A"/>
+                          </a:solidFill>
+                          <a:latin typeface="Calibri"/>
+                        </a:rPr>
+                        <a:t>max-flow via BFS dans le graphe résiduel</a:t>
+                      </a:r>
+                    </a:p>
+                  </a:txBody>
+                  <a:tcPr marL="91440" marR="91440" marT="27432" marB="27432" anchor="ctr">
+                    <a:solidFill>
+                      <a:srgbClr val="FDE9E0"/>
+                    </a:solidFill>
+                  </a:tcPr>
+                </a:tc>
+                <a:tc>
+                  <a:txBody>
+                    <a:bodyPr wrap="square"/>
+                    <a:lstStyle/>
+                    <a:p>
+                      <a:pPr algn="l"/>
+                      <a:r>
+                        <a:rPr sz="1600" b="1">
+                          <a:solidFill>
+                            <a:srgbClr val="0B1F2A"/>
+                          </a:solidFill>
+                          <a:latin typeface="Calibri"/>
+                        </a:rPr>
+                        <a:t>OUI : F fourmis en T étapes ?</a:t>
+                      </a:r>
+                    </a:p>
+                  </a:txBody>
+                  <a:tcPr marL="91440" marR="91440" marT="27432" marB="27432" anchor="ctr">
+                    <a:solidFill>
+                      <a:srgbClr val="FDE9E0"/>
+                    </a:solidFill>
+                  </a:tcPr>
+                </a:tc>
+              </a:tr>
+              <a:tr h="566928">
+                <a:tc>
+                  <a:txBody>
+                    <a:bodyPr wrap="square"/>
+                    <a:lstStyle/>
+                    <a:p>
+                      <a:pPr algn="l"/>
+                      <a:r>
+                        <a:rPr sz="1600" b="0">
+                          <a:solidFill>
+                            <a:srgbClr val="0B1F2A"/>
+                          </a:solidFill>
+                          <a:latin typeface="Calibri"/>
+                        </a:rPr>
+                        <a:t>Min-cost flow</a:t>
+                      </a:r>
+                    </a:p>
+                  </a:txBody>
+                  <a:tcPr marL="91440" marR="91440" marT="27432" marB="27432" anchor="ctr">
+                    <a:solidFill>
+                      <a:srgbClr val="FDE9E0"/>
+                    </a:solidFill>
+                  </a:tcPr>
+                </a:tc>
+                <a:tc>
+                  <a:txBody>
+                    <a:bodyPr wrap="square"/>
+                    <a:lstStyle/>
+                    <a:p>
+                      <a:pPr algn="l"/>
+                      <a:r>
+                        <a:rPr sz="1600" b="0">
+                          <a:solidFill>
+                            <a:srgbClr val="0B1F2A"/>
+                          </a:solidFill>
+                          <a:latin typeface="Calibri"/>
+                        </a:rPr>
+                        <a:t>départager les solutions optimales</a:t>
+                      </a:r>
+                    </a:p>
+                  </a:txBody>
+                  <a:tcPr marL="91440" marR="91440" marT="27432" marB="27432" anchor="ctr">
+                    <a:solidFill>
+                      <a:srgbClr val="FDE9E0"/>
+                    </a:solidFill>
+                  </a:tcPr>
+                </a:tc>
+                <a:tc>
+                  <a:txBody>
+                    <a:bodyPr wrap="square"/>
+                    <a:lstStyle/>
+                    <a:p>
+                      <a:pPr algn="l"/>
+                      <a:r>
+                        <a:rPr sz="1600" b="1">
+                          <a:solidFill>
+                            <a:srgbClr val="0B1F2A"/>
+                          </a:solidFill>
+                          <a:latin typeface="Calibri"/>
+                        </a:rPr>
+                        <a:t>OUI : à T fixé, trajets propres</a:t>
+                      </a:r>
+                    </a:p>
+                  </a:txBody>
+                  <a:tcPr marL="91440" marR="91440" marT="27432" marB="27432" anchor="ctr">
+                    <a:solidFill>
+                      <a:srgbClr val="FDE9E0"/>
+                    </a:solidFill>
+                  </a:tcPr>
+                </a:tc>
+              </a:tr>
+            </a:tbl>
+          </a:graphicData>
+        </a:graphic>
+      </p:graphicFrame>
     </p:spTree>
   </p:cSld>
   <p:clrMapOvr>

</xml_diff>